<commit_message>
reproductibilité : 3 entraînements indépendants, slide dédiée
- scripts/plot_seeds.py : superpose les courbes de plusieurs entraînements
  contre un adversaire (--lang fr|en).
- figures/seeds_CA_*.png : C+A, 3 entraînements, écart contre TrumpCount.
  À 2M parties : +4.35 / +4.94 / +5.06 pts (moyenne +4.8, écart-type 0.4).
- Présentation : slide « Three independent runs, the same result »,
  slide Next steps mise à jour (reproductibilité faite, démo humain vs agent).

Co-Authored-By: Claude Opus 5.5 <noreply@anthropic.com>
</commit_message>
<xml_diff>
--- a/presentation/belote_midterm_v3.pptx
+++ b/presentation/belote_midterm_v3.pptx
@@ -22,9 +22,10 @@
     <p:sldId id="270" r:id="rId16"/>
     <p:sldId id="271" r:id="rId17"/>
     <p:sldId id="272" r:id="rId18"/>
+    <p:sldId id="273" r:id="rId19"/>
   </p:sldIdLst>
   <p:notesMasterIdLst>
-    <p:notesMasterId r:id="rId19"/>
+    <p:notesMasterId r:id="rId20"/>
   </p:notesMasterIdLst>
   <p:sldSz cx="12192000" cy="6858000"/>
   <p:notesSz cx="6858000" cy="12192000"/>
@@ -123,7 +124,7 @@
   <p:extLst>
     <p:ext uri="{521415D9-36F7-43E2-AB2F-B90AF26B5E84}">
       <p14:sectionLst xmlns:p14="http://schemas.microsoft.com/office/powerpoint/2010/main">
-        <p14:section name="Introduction" id="{b036687e-ef44-3dc9-c891-4286ace2dc8c}">
+        <p14:section name="Introduction" id="{97b03087-89a1-b5cc-7b34-a3b432ac53a8}">
           <p14:sldIdLst>
             <p14:sldId id="256"/>
             <p14:sldId id="257"/>
@@ -131,7 +132,7 @@
             <p14:sldId id="259"/>
           </p14:sldIdLst>
         </p14:section>
-        <p14:section name="Method" id="{9305e20a-94e2-740d-aecf-161866b1864f}">
+        <p14:section name="Method" id="{a617d546-9ba9-a319-3f81-2c29575b805e}">
           <p14:sldIdLst>
             <p14:sldId id="260"/>
             <p14:sldId id="261"/>
@@ -139,7 +140,7 @@
             <p14:sldId id="263"/>
           </p14:sldIdLst>
         </p14:section>
-        <p14:section name="Results" id="{0668d608-a745-dc24-6ddd-51829f63c549}">
+        <p14:section name="Results" id="{d1ffbadb-fbab-bb50-fb37-01f4f205e22d}">
           <p14:sldIdLst>
             <p14:sldId id="264"/>
             <p14:sldId id="265"/>
@@ -148,12 +149,13 @@
             <p14:sldId id="268"/>
             <p14:sldId id="269"/>
             <p14:sldId id="270"/>
+            <p14:sldId id="271"/>
           </p14:sldIdLst>
         </p14:section>
-        <p14:section name="Conclusion" id="{b39978f5-2472-abc3-c555-f2b2840e6c05}">
+        <p14:section name="Conclusion" id="{8f4007e6-973a-5701-c604-47fd63a0eaf6}">
           <p14:sldIdLst>
-            <p14:sldId id="271"/>
             <p14:sldId id="272"/>
+            <p14:sldId id="273"/>
           </p14:sldIdLst>
         </p14:section>
       </p14:sectionLst>
@@ -1566,7 +1568,7 @@
           <a:p>
             <a:r>
               <a:rPr lang="en-US" dirty="0"/>
-              <a:t/>
+              <a:t>Same configuration (no win bonus, lr 3e-4), three different random seeds. Each agent re-evaluated at 2M games on 6 000 duplicate games per opponent.</a:t>
             </a:r>
             <a:endParaRPr lang="en-US" dirty="0"/>
           </a:p>
@@ -1854,6 +1856,94 @@
             <a:fld id="{F7021451-1387-4CA6-816F-3879F97B5CBC}" type="slidenum">
               <a:rPr lang="en-US"/>
               <a:t>17</a:t>
+            </a:fld>
+            <a:endParaRPr lang="en-US"/>
+          </a:p>
+        </p:txBody>
+      </p:sp>
+    </p:spTree>
+    <p:extLst>
+      <p:ext uri="{BB962C8B-B14F-4D97-AF65-F5344CB8AC3E}">
+        <p14:creationId xmlns:p14="http://schemas.microsoft.com/office/powerpoint/2010/main" val="1024086991"/>
+      </p:ext>
+    </p:extLst>
+  </p:cSld>
+  <p:clrMapOvr>
+    <a:masterClrMapping/>
+  </p:clrMapOvr>
+</p:notes>
+</file>
+
+<file path=ppt/notesSlides/notesSlide18.xml><?xml version="1.0" encoding="utf-8"?>
+<p:notes xmlns:a="http://schemas.openxmlformats.org/drawingml/2006/main" xmlns:r="http://schemas.openxmlformats.org/officeDocument/2006/relationships" xmlns:p="http://schemas.openxmlformats.org/presentationml/2006/main">
+  <p:cSld>
+    <p:spTree>
+      <p:nvGrpSpPr>
+        <p:cNvPr id="1" name=""/>
+        <p:cNvGrpSpPr/>
+        <p:nvPr/>
+      </p:nvGrpSpPr>
+      <p:grpSpPr>
+        <a:xfrm>
+          <a:off x="0" y="0"/>
+          <a:ext cx="0" cy="0"/>
+          <a:chOff x="0" y="0"/>
+          <a:chExt cx="0" cy="0"/>
+        </a:xfrm>
+      </p:grpSpPr>
+      <p:sp>
+        <p:nvSpPr>
+          <p:cNvPr id="2" name="Slide Image Placeholder 1"/>
+          <p:cNvSpPr>
+            <a:spLocks noGrp="1" noRot="1" noChangeAspect="1"/>
+          </p:cNvSpPr>
+          <p:nvPr>
+            <p:ph type="sldImg"/>
+          </p:nvPr>
+        </p:nvSpPr>
+        <p:spPr/>
+      </p:sp>
+      <p:sp>
+        <p:nvSpPr>
+          <p:cNvPr id="3" name="Notes Placeholder 2"/>
+          <p:cNvSpPr>
+            <a:spLocks noGrp="1"/>
+          </p:cNvSpPr>
+          <p:nvPr>
+            <p:ph type="body" idx="1"/>
+          </p:nvPr>
+        </p:nvSpPr>
+        <p:spPr/>
+        <p:txBody>
+          <a:bodyPr/>
+          <a:lstStyle/>
+          <a:p>
+            <a:r>
+              <a:rPr lang="en-US" dirty="0"/>
+              <a:t/>
+            </a:r>
+            <a:endParaRPr lang="en-US" dirty="0"/>
+          </a:p>
+        </p:txBody>
+      </p:sp>
+      <p:sp>
+        <p:nvSpPr>
+          <p:cNvPr id="4" name="Slide Number Placeholder 3"/>
+          <p:cNvSpPr>
+            <a:spLocks noGrp="1"/>
+          </p:cNvSpPr>
+          <p:nvPr>
+            <p:ph type="sldNum" sz="quarter" idx="10"/>
+          </p:nvPr>
+        </p:nvSpPr>
+        <p:spPr/>
+        <p:txBody>
+          <a:bodyPr/>
+          <a:lstStyle/>
+          <a:p>
+            <a:fld id="{F7021451-1387-4CA6-816F-3879F97B5CBC}" type="slidenum">
+              <a:rPr lang="en-US"/>
+              <a:t>18</a:t>
             </a:fld>
             <a:endParaRPr lang="en-US"/>
           </a:p>
@@ -7994,7 +8084,7 @@
                 <a:ea typeface="Courier New" pitchFamily="34" charset="-122"/>
                 <a:cs typeface="Courier New" pitchFamily="34" charset="-120"/>
               </a:rPr>
-              <a:t>13 / SELF-PLAY</a:t>
+              <a:t>13 / REPRODUCIBILITY</a:t>
             </a:r>
             <a:endParaRPr lang="en-US" sz="1200" dirty="0"/>
           </a:p>
@@ -8032,26 +8122,50 @@
                   <a:schemeClr val="tx1"/>
                 </a:solidFill>
               </a:rPr>
-              <a:t>Real progress in self-play — until ~2M games</a:t>
+              <a:t>Three independent runs, the same result</a:t>
             </a:r>
             <a:endParaRPr lang="en-US" sz="3400" dirty="0"/>
           </a:p>
         </p:txBody>
       </p:sp>
-      <p:sp>
-        <p:nvSpPr>
-          <p:cNvPr id="4" name="checkpoint chart card"/>
+      <p:pic>
+        <p:nvPicPr>
+          <p:cNvPr id="4" name="three seeds learning curves" descr="fig_seeds.png">    </p:cNvPr>
+          <p:cNvPicPr>
+            <a:picLocks noChangeAspect="1"/>
+          </p:cNvPicPr>
+          <p:nvPr/>
+        </p:nvPicPr>
+        <p:blipFill>
+          <a:blip r:embed="rId1"/>
+          <a:stretch>
+            <a:fillRect/>
+          </a:stretch>
+        </p:blipFill>
+        <p:spPr>
+          <a:xfrm>
+            <a:off x="548640" y="1783080"/>
+            <a:ext cx="7754112" cy="4343400"/>
+          </a:xfrm>
+          <a:prstGeom prst="rect">
+            <a:avLst/>
+          </a:prstGeom>
+        </p:spPr>
+      </p:pic>
+      <p:sp>
+        <p:nvSpPr>
+          <p:cNvPr id="5" name="seeds table card"/>
           <p:cNvSpPr/>
           <p:nvPr/>
         </p:nvSpPr>
         <p:spPr>
           <a:xfrm>
-            <a:off x="548640" y="1783080"/>
-            <a:ext cx="6949440" cy="4343400"/>
+            <a:off x="8595360" y="1783080"/>
+            <a:ext cx="3017520" cy="2743200"/>
           </a:xfrm>
           <a:prstGeom prst="roundRect">
             <a:avLst>
-              <a:gd name="adj" fmla="val 1684"/>
+              <a:gd name="adj" fmla="val 2667"/>
             </a:avLst>
           </a:prstGeom>
           <a:solidFill>
@@ -8067,13 +8181,13 @@
       </p:sp>
       <p:sp>
         <p:nvSpPr>
-          <p:cNvPr id="5" name="Text 3"/>
-          <p:cNvSpPr txBox="1"/>
-          <p:nvPr/>
-        </p:nvSpPr>
-        <p:spPr>
-          <a:xfrm>
-            <a:off x="822960" y="2011680"/>
+          <p:cNvPr id="6" name="Text 3"/>
+          <p:cNvSpPr txBox="1"/>
+          <p:nvPr/>
+        </p:nvSpPr>
+        <p:spPr>
+          <a:xfrm>
+            <a:off x="8823960" y="1965960"/>
             <a:ext cx="6400800" cy="274320"/>
           </a:xfrm>
           <a:prstGeom prst="rect">
@@ -8098,28 +8212,12 @@
                 <a:ea typeface="Courier New" pitchFamily="34" charset="-122"/>
                 <a:cs typeface="Courier New" pitchFamily="34" charset="-120"/>
               </a:rPr>
-              <a:t>FINAL AGENT VS ITS OWN EARLIER VERSIONS</a:t>
+              <a:t>VS TRUMPCOUNT AT 2M GAMES</a:t>
             </a:r>
             <a:endParaRPr lang="en-US" sz="1100" dirty="0"/>
           </a:p>
         </p:txBody>
       </p:sp>
-      <p:graphicFrame>
-        <p:nvGraphicFramePr>
-          <p:cNvPr id="6" name="checkpoint chart" descr=""/>
-          <p:cNvGraphicFramePr/>
-          <p:nvPr/>
-        </p:nvGraphicFramePr>
-        <p:xfrm>
-          <a:off x="685800" y="2331720"/>
-          <a:ext cx="6675120" cy="3520440"/>
-        </p:xfrm>
-        <a:graphic xmlns:a="http://schemas.openxmlformats.org/drawingml/2006/main">
-          <a:graphicData uri="http://schemas.openxmlformats.org/drawingml/2006/chart">
-            <c:chart xmlns:c="http://schemas.openxmlformats.org/drawingml/2006/chart" r:id="rId1"/>
-          </a:graphicData>
-        </a:graphic>
-      </p:graphicFrame>
       <p:sp>
         <p:nvSpPr>
           <p:cNvPr id="7" name="Text 4"/>
@@ -8128,48 +8226,393 @@
         </p:nvSpPr>
         <p:spPr>
           <a:xfrm>
-            <a:off x="822960" y="5806440"/>
-            <a:ext cx="6400800" cy="274320"/>
-          </a:xfrm>
-          <a:prstGeom prst="rect">
-            <a:avLst/>
-          </a:prstGeom>
-          <a:noFill/>
-          <a:ln/>
-        </p:spPr>
-        <p:txBody>
-          <a:bodyPr wrap="square" lIns="0" tIns="0" rIns="0" bIns="0" rtlCol="0" anchor="t"/>
+            <a:off x="8823960" y="2377440"/>
+            <a:ext cx="914400" cy="365760"/>
+          </a:xfrm>
+          <a:prstGeom prst="rect">
+            <a:avLst/>
+          </a:prstGeom>
+          <a:noFill/>
+          <a:ln/>
+        </p:spPr>
+        <p:txBody>
+          <a:bodyPr wrap="square" lIns="0" tIns="0" rIns="0" bIns="0" rtlCol="0" anchor="ctr"/>
           <a:lstStyle/>
           <a:p>
             <a:pPr indent="0" marL="0">
               <a:buNone/>
             </a:pPr>
             <a:r>
-              <a:rPr lang="en-US" sz="1100" dirty="0">
+              <a:rPr lang="en-US" sz="1400" b="1" dirty="0">
+                <a:solidFill>
+                  <a:schemeClr val="tx1"/>
+                </a:solidFill>
+              </a:rPr>
+              <a:t>Run 1</a:t>
+            </a:r>
+            <a:endParaRPr lang="en-US" sz="1400" dirty="0"/>
+          </a:p>
+        </p:txBody>
+      </p:sp>
+      <p:sp>
+        <p:nvSpPr>
+          <p:cNvPr id="8" name="Text 5"/>
+          <p:cNvSpPr txBox="1"/>
+          <p:nvPr/>
+        </p:nvSpPr>
+        <p:spPr>
+          <a:xfrm>
+            <a:off x="9692640" y="2377440"/>
+            <a:ext cx="914400" cy="365760"/>
+          </a:xfrm>
+          <a:prstGeom prst="rect">
+            <a:avLst/>
+          </a:prstGeom>
+          <a:noFill/>
+          <a:ln/>
+        </p:spPr>
+        <p:txBody>
+          <a:bodyPr wrap="square" lIns="0" tIns="0" rIns="0" bIns="0" rtlCol="0" anchor="ctr"/>
+          <a:lstStyle/>
+          <a:p>
+            <a:pPr algn="r" indent="0" marL="0">
+              <a:buNone/>
+            </a:pPr>
+            <a:r>
+              <a:rPr lang="en-US" sz="1400" b="1" dirty="0">
+                <a:solidFill>
+                  <a:schemeClr val="tx1"/>
+                </a:solidFill>
+                <a:latin typeface="Courier New" pitchFamily="34" charset="0"/>
+                <a:ea typeface="Courier New" pitchFamily="34" charset="-122"/>
+                <a:cs typeface="Courier New" pitchFamily="34" charset="-120"/>
+              </a:rPr>
+              <a:t>+4.35</a:t>
+            </a:r>
+            <a:endParaRPr lang="en-US" sz="1400" dirty="0"/>
+          </a:p>
+        </p:txBody>
+      </p:sp>
+      <p:sp>
+        <p:nvSpPr>
+          <p:cNvPr id="9" name="Text 6"/>
+          <p:cNvSpPr txBox="1"/>
+          <p:nvPr/>
+        </p:nvSpPr>
+        <p:spPr>
+          <a:xfrm>
+            <a:off x="10652760" y="2377440"/>
+            <a:ext cx="777240" cy="365760"/>
+          </a:xfrm>
+          <a:prstGeom prst="rect">
+            <a:avLst/>
+          </a:prstGeom>
+          <a:noFill/>
+          <a:ln/>
+        </p:spPr>
+        <p:txBody>
+          <a:bodyPr wrap="square" lIns="0" tIns="0" rIns="0" bIns="0" rtlCol="0" anchor="ctr"/>
+          <a:lstStyle/>
+          <a:p>
+            <a:pPr algn="r" indent="0" marL="0">
+              <a:buNone/>
+            </a:pPr>
+            <a:r>
+              <a:rPr lang="en-US" sz="1200" dirty="0">
                 <a:solidFill>
                   <a:schemeClr val="tx2"/>
                 </a:solidFill>
-              </a:rPr>
-              <a:t>Opponent checkpoint (training games) · 1 000 duplicate deals each · ±0.5–0.9 pts</a:t>
-            </a:r>
-            <a:endParaRPr lang="en-US" sz="1100" dirty="0"/>
-          </a:p>
-        </p:txBody>
-      </p:sp>
-      <p:sp>
-        <p:nvSpPr>
-          <p:cNvPr id="8" name="plateau takeaway card"/>
+                <a:latin typeface="Courier New" pitchFamily="34" charset="0"/>
+                <a:ea typeface="Courier New" pitchFamily="34" charset="-122"/>
+                <a:cs typeface="Courier New" pitchFamily="34" charset="-120"/>
+              </a:rPr>
+              <a:t>55.9%</a:t>
+            </a:r>
+            <a:endParaRPr lang="en-US" sz="1200" dirty="0"/>
+          </a:p>
+        </p:txBody>
+      </p:sp>
+      <p:sp>
+        <p:nvSpPr>
+          <p:cNvPr id="10" name="Text 7"/>
+          <p:cNvSpPr txBox="1"/>
+          <p:nvPr/>
+        </p:nvSpPr>
+        <p:spPr>
+          <a:xfrm>
+            <a:off x="8823960" y="2834640"/>
+            <a:ext cx="914400" cy="365760"/>
+          </a:xfrm>
+          <a:prstGeom prst="rect">
+            <a:avLst/>
+          </a:prstGeom>
+          <a:noFill/>
+          <a:ln/>
+        </p:spPr>
+        <p:txBody>
+          <a:bodyPr wrap="square" lIns="0" tIns="0" rIns="0" bIns="0" rtlCol="0" anchor="ctr"/>
+          <a:lstStyle/>
+          <a:p>
+            <a:pPr indent="0" marL="0">
+              <a:buNone/>
+            </a:pPr>
+            <a:r>
+              <a:rPr lang="en-US" sz="1400" b="1" dirty="0">
+                <a:solidFill>
+                  <a:schemeClr val="tx1"/>
+                </a:solidFill>
+              </a:rPr>
+              <a:t>Run 2</a:t>
+            </a:r>
+            <a:endParaRPr lang="en-US" sz="1400" dirty="0"/>
+          </a:p>
+        </p:txBody>
+      </p:sp>
+      <p:sp>
+        <p:nvSpPr>
+          <p:cNvPr id="11" name="Text 8"/>
+          <p:cNvSpPr txBox="1"/>
+          <p:nvPr/>
+        </p:nvSpPr>
+        <p:spPr>
+          <a:xfrm>
+            <a:off x="9692640" y="2834640"/>
+            <a:ext cx="914400" cy="365760"/>
+          </a:xfrm>
+          <a:prstGeom prst="rect">
+            <a:avLst/>
+          </a:prstGeom>
+          <a:noFill/>
+          <a:ln/>
+        </p:spPr>
+        <p:txBody>
+          <a:bodyPr wrap="square" lIns="0" tIns="0" rIns="0" bIns="0" rtlCol="0" anchor="ctr"/>
+          <a:lstStyle/>
+          <a:p>
+            <a:pPr algn="r" indent="0" marL="0">
+              <a:buNone/>
+            </a:pPr>
+            <a:r>
+              <a:rPr lang="en-US" sz="1400" b="1" dirty="0">
+                <a:solidFill>
+                  <a:schemeClr val="tx1"/>
+                </a:solidFill>
+                <a:latin typeface="Courier New" pitchFamily="34" charset="0"/>
+                <a:ea typeface="Courier New" pitchFamily="34" charset="-122"/>
+                <a:cs typeface="Courier New" pitchFamily="34" charset="-120"/>
+              </a:rPr>
+              <a:t>+4.94</a:t>
+            </a:r>
+            <a:endParaRPr lang="en-US" sz="1400" dirty="0"/>
+          </a:p>
+        </p:txBody>
+      </p:sp>
+      <p:sp>
+        <p:nvSpPr>
+          <p:cNvPr id="12" name="Text 9"/>
+          <p:cNvSpPr txBox="1"/>
+          <p:nvPr/>
+        </p:nvSpPr>
+        <p:spPr>
+          <a:xfrm>
+            <a:off x="10652760" y="2834640"/>
+            <a:ext cx="777240" cy="365760"/>
+          </a:xfrm>
+          <a:prstGeom prst="rect">
+            <a:avLst/>
+          </a:prstGeom>
+          <a:noFill/>
+          <a:ln/>
+        </p:spPr>
+        <p:txBody>
+          <a:bodyPr wrap="square" lIns="0" tIns="0" rIns="0" bIns="0" rtlCol="0" anchor="ctr"/>
+          <a:lstStyle/>
+          <a:p>
+            <a:pPr algn="r" indent="0" marL="0">
+              <a:buNone/>
+            </a:pPr>
+            <a:r>
+              <a:rPr lang="en-US" sz="1200" dirty="0">
+                <a:solidFill>
+                  <a:schemeClr val="tx2"/>
+                </a:solidFill>
+                <a:latin typeface="Courier New" pitchFamily="34" charset="0"/>
+                <a:ea typeface="Courier New" pitchFamily="34" charset="-122"/>
+                <a:cs typeface="Courier New" pitchFamily="34" charset="-120"/>
+              </a:rPr>
+              <a:t>56.8%</a:t>
+            </a:r>
+            <a:endParaRPr lang="en-US" sz="1200" dirty="0"/>
+          </a:p>
+        </p:txBody>
+      </p:sp>
+      <p:sp>
+        <p:nvSpPr>
+          <p:cNvPr id="13" name="Text 10"/>
+          <p:cNvSpPr txBox="1"/>
+          <p:nvPr/>
+        </p:nvSpPr>
+        <p:spPr>
+          <a:xfrm>
+            <a:off x="8823960" y="3291840"/>
+            <a:ext cx="914400" cy="365760"/>
+          </a:xfrm>
+          <a:prstGeom prst="rect">
+            <a:avLst/>
+          </a:prstGeom>
+          <a:noFill/>
+          <a:ln/>
+        </p:spPr>
+        <p:txBody>
+          <a:bodyPr wrap="square" lIns="0" tIns="0" rIns="0" bIns="0" rtlCol="0" anchor="ctr"/>
+          <a:lstStyle/>
+          <a:p>
+            <a:pPr indent="0" marL="0">
+              <a:buNone/>
+            </a:pPr>
+            <a:r>
+              <a:rPr lang="en-US" sz="1400" b="1" dirty="0">
+                <a:solidFill>
+                  <a:schemeClr val="tx1"/>
+                </a:solidFill>
+              </a:rPr>
+              <a:t>Run 3</a:t>
+            </a:r>
+            <a:endParaRPr lang="en-US" sz="1400" dirty="0"/>
+          </a:p>
+        </p:txBody>
+      </p:sp>
+      <p:sp>
+        <p:nvSpPr>
+          <p:cNvPr id="14" name="Text 11"/>
+          <p:cNvSpPr txBox="1"/>
+          <p:nvPr/>
+        </p:nvSpPr>
+        <p:spPr>
+          <a:xfrm>
+            <a:off x="9692640" y="3291840"/>
+            <a:ext cx="914400" cy="365760"/>
+          </a:xfrm>
+          <a:prstGeom prst="rect">
+            <a:avLst/>
+          </a:prstGeom>
+          <a:noFill/>
+          <a:ln/>
+        </p:spPr>
+        <p:txBody>
+          <a:bodyPr wrap="square" lIns="0" tIns="0" rIns="0" bIns="0" rtlCol="0" anchor="ctr"/>
+          <a:lstStyle/>
+          <a:p>
+            <a:pPr algn="r" indent="0" marL="0">
+              <a:buNone/>
+            </a:pPr>
+            <a:r>
+              <a:rPr lang="en-US" sz="1400" b="1" dirty="0">
+                <a:solidFill>
+                  <a:schemeClr val="tx1"/>
+                </a:solidFill>
+                <a:latin typeface="Courier New" pitchFamily="34" charset="0"/>
+                <a:ea typeface="Courier New" pitchFamily="34" charset="-122"/>
+                <a:cs typeface="Courier New" pitchFamily="34" charset="-120"/>
+              </a:rPr>
+              <a:t>+5.06</a:t>
+            </a:r>
+            <a:endParaRPr lang="en-US" sz="1400" dirty="0"/>
+          </a:p>
+        </p:txBody>
+      </p:sp>
+      <p:sp>
+        <p:nvSpPr>
+          <p:cNvPr id="15" name="Text 12"/>
+          <p:cNvSpPr txBox="1"/>
+          <p:nvPr/>
+        </p:nvSpPr>
+        <p:spPr>
+          <a:xfrm>
+            <a:off x="10652760" y="3291840"/>
+            <a:ext cx="777240" cy="365760"/>
+          </a:xfrm>
+          <a:prstGeom prst="rect">
+            <a:avLst/>
+          </a:prstGeom>
+          <a:noFill/>
+          <a:ln/>
+        </p:spPr>
+        <p:txBody>
+          <a:bodyPr wrap="square" lIns="0" tIns="0" rIns="0" bIns="0" rtlCol="0" anchor="ctr"/>
+          <a:lstStyle/>
+          <a:p>
+            <a:pPr algn="r" indent="0" marL="0">
+              <a:buNone/>
+            </a:pPr>
+            <a:r>
+              <a:rPr lang="en-US" sz="1200" dirty="0">
+                <a:solidFill>
+                  <a:schemeClr val="tx2"/>
+                </a:solidFill>
+                <a:latin typeface="Courier New" pitchFamily="34" charset="0"/>
+                <a:ea typeface="Courier New" pitchFamily="34" charset="-122"/>
+                <a:cs typeface="Courier New" pitchFamily="34" charset="-120"/>
+              </a:rPr>
+              <a:t>55.9%</a:t>
+            </a:r>
+            <a:endParaRPr lang="en-US" sz="1200" dirty="0"/>
+          </a:p>
+        </p:txBody>
+      </p:sp>
+      <p:sp>
+        <p:nvSpPr>
+          <p:cNvPr id="16" name="Text 13"/>
+          <p:cNvSpPr txBox="1"/>
+          <p:nvPr/>
+        </p:nvSpPr>
+        <p:spPr>
+          <a:xfrm>
+            <a:off x="8823960" y="3840480"/>
+            <a:ext cx="2651760" cy="457200"/>
+          </a:xfrm>
+          <a:prstGeom prst="rect">
+            <a:avLst/>
+          </a:prstGeom>
+          <a:noFill/>
+          <a:ln/>
+        </p:spPr>
+        <p:txBody>
+          <a:bodyPr wrap="square" lIns="0" tIns="0" rIns="0" bIns="0" rtlCol="0" anchor="ctr"/>
+          <a:lstStyle/>
+          <a:p>
+            <a:pPr indent="0" marL="0">
+              <a:buNone/>
+            </a:pPr>
+            <a:r>
+              <a:rPr lang="en-US" sz="1000" dirty="0">
+                <a:solidFill>
+                  <a:schemeClr val="tx2"/>
+                </a:solidFill>
+                <a:latin typeface="Courier New" pitchFamily="34" charset="0"/>
+                <a:ea typeface="Courier New" pitchFamily="34" charset="-122"/>
+                <a:cs typeface="Courier New" pitchFamily="34" charset="-120"/>
+              </a:rPr>
+              <a:t>pts / game · win rate · ±0.4 pts each</a:t>
+            </a:r>
+            <a:endParaRPr lang="en-US" sz="1000" dirty="0"/>
+          </a:p>
+        </p:txBody>
+      </p:sp>
+      <p:sp>
+        <p:nvSpPr>
+          <p:cNvPr id="17" name="seeds mean card"/>
           <p:cNvSpPr/>
           <p:nvPr/>
         </p:nvSpPr>
         <p:spPr>
           <a:xfrm>
-            <a:off x="7772400" y="1783080"/>
-            <a:ext cx="3840480" cy="4343400"/>
+            <a:off x="8595360" y="4709160"/>
+            <a:ext cx="3017520" cy="1417320"/>
           </a:xfrm>
           <a:prstGeom prst="roundRect">
             <a:avLst>
-              <a:gd name="adj" fmla="val 1905"/>
+              <a:gd name="adj" fmla="val 5161"/>
             </a:avLst>
           </a:prstGeom>
           <a:solidFill>
@@ -8185,14 +8628,14 @@
       </p:sp>
       <p:sp>
         <p:nvSpPr>
-          <p:cNvPr id="9" name="Text 6"/>
-          <p:cNvSpPr txBox="1"/>
-          <p:nvPr/>
-        </p:nvSpPr>
-        <p:spPr>
-          <a:xfrm>
-            <a:off x="8046720" y="2011680"/>
-            <a:ext cx="6400800" cy="274320"/>
+          <p:cNvPr id="18" name="Text 15"/>
+          <p:cNvSpPr txBox="1"/>
+          <p:nvPr/>
+        </p:nvSpPr>
+        <p:spPr>
+          <a:xfrm>
+            <a:off x="8823960" y="4846320"/>
+            <a:ext cx="2651760" cy="594360"/>
           </a:xfrm>
           <a:prstGeom prst="rect">
             <a:avLst/>
@@ -8208,7 +8651,7 @@
               <a:buNone/>
             </a:pPr>
             <a:r>
-              <a:rPr lang="en-US" sz="1100" b="1" dirty="0">
+              <a:rPr lang="en-US" sz="3000" b="1" dirty="0">
                 <a:solidFill>
                   <a:schemeClr val="accent1"/>
                 </a:solidFill>
@@ -8216,22 +8659,36 @@
                 <a:ea typeface="Courier New" pitchFamily="34" charset="-122"/>
                 <a:cs typeface="Courier New" pitchFamily="34" charset="-120"/>
               </a:rPr>
-              <a:t>TAKEAWAYS</a:t>
-            </a:r>
-            <a:endParaRPr lang="en-US" sz="1100" dirty="0"/>
-          </a:p>
-        </p:txBody>
-      </p:sp>
-      <p:sp>
-        <p:nvSpPr>
-          <p:cNvPr id="10" name="Text 7"/>
-          <p:cNvSpPr txBox="1"/>
-          <p:nvPr/>
-        </p:nvSpPr>
-        <p:spPr>
-          <a:xfrm>
-            <a:off x="8046720" y="2423160"/>
-            <a:ext cx="3383280" cy="3566160"/>
+              <a:t>+4.8</a:t>
+            </a:r>
+            <a:pPr indent="0" marL="0">
+              <a:buNone/>
+            </a:pPr>
+            <a:r>
+              <a:rPr lang="en-US" sz="1400" dirty="0">
+                <a:solidFill>
+                  <a:schemeClr val="tx2"/>
+                </a:solidFill>
+                <a:latin typeface="Courier New" pitchFamily="34" charset="0"/>
+                <a:ea typeface="Courier New" pitchFamily="34" charset="-122"/>
+                <a:cs typeface="Courier New" pitchFamily="34" charset="-120"/>
+              </a:rPr>
+              <a:t>  ±0.4</a:t>
+            </a:r>
+            <a:endParaRPr lang="en-US" sz="3000" dirty="0"/>
+          </a:p>
+        </p:txBody>
+      </p:sp>
+      <p:sp>
+        <p:nvSpPr>
+          <p:cNvPr id="19" name="Text 16"/>
+          <p:cNvSpPr txBox="1"/>
+          <p:nvPr/>
+        </p:nvSpPr>
+        <p:spPr>
+          <a:xfrm>
+            <a:off x="8823960" y="5440680"/>
+            <a:ext cx="2651760" cy="594360"/>
           </a:xfrm>
           <a:prstGeom prst="rect">
             <a:avLst/>
@@ -8247,103 +8704,14 @@
               <a:buNone/>
             </a:pPr>
             <a:r>
-              <a:rPr lang="en-US" sz="1400" b="1" dirty="0">
-                <a:solidFill>
-                  <a:schemeClr val="tx1"/>
-                </a:solidFill>
-              </a:rPr>
-              <a:t>It improves against itself, </a:t>
-            </a:r>
-            <a:pPr indent="0" marL="0">
-              <a:buNone/>
-            </a:pPr>
-            <a:r>
-              <a:rPr lang="en-US" sz="1400" dirty="0">
-                <a:solidFill>
-                  <a:schemeClr val="tx1"/>
-                </a:solidFill>
-              </a:rPr>
-              <a:t>not only against our heuristics.</a:t>
-            </a:r>
-            <a:endParaRPr lang="en-US" sz="1400" dirty="0"/>
-          </a:p>
-          <a:p>
-            <a:pPr indent="0" marL="0">
-              <a:buNone/>
-            </a:pPr>
-            <a:r>
-              <a:rPr lang="en-US" sz="800" dirty="0">
-                <a:solidFill>
-                  <a:schemeClr val="tx1"/>
-                </a:solidFill>
-              </a:rPr>
-              <a:t> </a:t>
-            </a:r>
-            <a:endParaRPr lang="en-US" sz="1400" dirty="0"/>
-          </a:p>
-          <a:p>
-            <a:pPr indent="0" marL="0">
-              <a:buNone/>
-            </a:pPr>
-            <a:r>
-              <a:rPr lang="en-US" sz="1400" b="1" dirty="0">
-                <a:solidFill>
-                  <a:schemeClr val="tx1"/>
-                </a:solidFill>
-              </a:rPr>
-              <a:t>Gains shrink, then stop near 1.5–2M games: </a:t>
-            </a:r>
-            <a:pPr indent="0" marL="0">
-              <a:buNone/>
-            </a:pPr>
-            <a:r>
-              <a:rPr lang="en-US" sz="1400" dirty="0">
-                <a:solidFill>
-                  <a:schemeClr val="tx1"/>
-                </a:solidFill>
-              </a:rPr>
-              <a:t>the last million added nothing.</a:t>
-            </a:r>
-            <a:endParaRPr lang="en-US" sz="1400" dirty="0"/>
-          </a:p>
-          <a:p>
-            <a:pPr indent="0" marL="0">
-              <a:buNone/>
-            </a:pPr>
-            <a:r>
-              <a:rPr lang="en-US" sz="800" dirty="0">
-                <a:solidFill>
-                  <a:schemeClr val="tx1"/>
-                </a:solidFill>
-              </a:rPr>
-              <a:t> </a:t>
-            </a:r>
-            <a:endParaRPr lang="en-US" sz="1400" dirty="0"/>
-          </a:p>
-          <a:p>
-            <a:pPr indent="0" marL="0">
-              <a:buNone/>
-            </a:pPr>
-            <a:r>
-              <a:rPr lang="en-US" sz="1400" b="1" dirty="0">
-                <a:solidFill>
-                  <a:schemeClr val="accent1"/>
-                </a:solidFill>
-              </a:rPr>
-              <a:t>Going further needs a better agent </a:t>
-            </a:r>
-            <a:pPr indent="0" marL="0">
-              <a:buNone/>
-            </a:pPr>
-            <a:r>
-              <a:rPr lang="en-US" sz="1400" dirty="0">
-                <a:solidFill>
-                  <a:schemeClr val="tx1"/>
-                </a:solidFill>
-              </a:rPr>
-              <a:t>(memory, bigger net, league self-play), not longer training.</a:t>
-            </a:r>
-            <a:endParaRPr lang="en-US" sz="1400" dirty="0"/>
+              <a:rPr lang="en-US" sz="1200" dirty="0">
+                <a:solidFill>
+                  <a:schemeClr val="tx2"/>
+                </a:solidFill>
+              </a:rPr>
+              <a:t>mean across seeds — the spread is no larger than measurement noise</a:t>
+            </a:r>
+            <a:endParaRPr lang="en-US" sz="1200" dirty="0"/>
           </a:p>
         </p:txBody>
       </p:sp>
@@ -8455,7 +8823,7 @@
                 <a:ea typeface="Courier New" pitchFamily="34" charset="-122"/>
                 <a:cs typeface="Courier New" pitchFamily="34" charset="-120"/>
               </a:rPr>
-              <a:t>14 / BEHAVIOUR</a:t>
+              <a:t>14 / SELF-PLAY</a:t>
             </a:r>
             <a:endParaRPr lang="en-US" sz="1200" dirty="0"/>
           </a:p>
@@ -8493,7 +8861,7 @@
                   <a:schemeClr val="tx1"/>
                 </a:solidFill>
               </a:rPr>
-              <a:t>What the agent learned on its own</a:t>
+              <a:t>Real progress in self-play — until ~2M games</a:t>
             </a:r>
             <a:endParaRPr lang="en-US" sz="3400" dirty="0"/>
           </a:p>
@@ -8501,7 +8869,7 @@
       </p:sp>
       <p:sp>
         <p:nvSpPr>
-          <p:cNvPr id="4" name="good deal card"/>
+          <p:cNvPr id="4" name="checkpoint chart card"/>
           <p:cNvSpPr/>
           <p:nvPr/>
         </p:nvSpPr>
@@ -8559,1030 +8927,78 @@
                 <a:ea typeface="Courier New" pitchFamily="34" charset="-122"/>
                 <a:cs typeface="Courier New" pitchFamily="34" charset="-120"/>
               </a:rPr>
-              <a:t>SAME HAND, TWO PLAYERS · TRUMP ♦</a:t>
+              <a:t>FINAL AGENT VS ITS OWN EARLIER VERSIONS</a:t>
             </a:r>
             <a:endParaRPr lang="en-US" sz="1100" dirty="0"/>
           </a:p>
         </p:txBody>
       </p:sp>
-      <p:sp>
-        <p:nvSpPr>
-          <p:cNvPr id="6" name="card 8D"/>
+      <p:graphicFrame>
+        <p:nvGraphicFramePr>
+          <p:cNvPr id="6" name="checkpoint chart" descr=""/>
+          <p:cNvGraphicFramePr/>
+          <p:nvPr/>
+        </p:nvGraphicFramePr>
+        <p:xfrm>
+          <a:off x="685800" y="2331720"/>
+          <a:ext cx="6675120" cy="3520440"/>
+        </p:xfrm>
+        <a:graphic xmlns:a="http://schemas.openxmlformats.org/drawingml/2006/main">
+          <a:graphicData uri="http://schemas.openxmlformats.org/drawingml/2006/chart">
+            <c:chart xmlns:c="http://schemas.openxmlformats.org/drawingml/2006/chart" r:id="rId1"/>
+          </a:graphicData>
+        </a:graphic>
+      </p:graphicFrame>
+      <p:sp>
+        <p:nvSpPr>
+          <p:cNvPr id="7" name="Text 4"/>
+          <p:cNvSpPr txBox="1"/>
+          <p:nvPr/>
+        </p:nvSpPr>
+        <p:spPr>
+          <a:xfrm>
+            <a:off x="822960" y="5806440"/>
+            <a:ext cx="6400800" cy="274320"/>
+          </a:xfrm>
+          <a:prstGeom prst="rect">
+            <a:avLst/>
+          </a:prstGeom>
+          <a:noFill/>
+          <a:ln/>
+        </p:spPr>
+        <p:txBody>
+          <a:bodyPr wrap="square" lIns="0" tIns="0" rIns="0" bIns="0" rtlCol="0" anchor="t"/>
+          <a:lstStyle/>
+          <a:p>
+            <a:pPr indent="0" marL="0">
+              <a:buNone/>
+            </a:pPr>
+            <a:r>
+              <a:rPr lang="en-US" sz="1100" dirty="0">
+                <a:solidFill>
+                  <a:schemeClr val="tx2"/>
+                </a:solidFill>
+              </a:rPr>
+              <a:t>Opponent checkpoint (training games) · 1 000 duplicate deals each · ±0.5–0.9 pts</a:t>
+            </a:r>
+            <a:endParaRPr lang="en-US" sz="1100" dirty="0"/>
+          </a:p>
+        </p:txBody>
+      </p:sp>
+      <p:sp>
+        <p:nvSpPr>
+          <p:cNvPr id="8" name="plateau takeaway card"/>
           <p:cNvSpPr/>
           <p:nvPr/>
         </p:nvSpPr>
         <p:spPr>
           <a:xfrm>
-            <a:off x="822960" y="2377440"/>
-            <a:ext cx="566928" cy="786384"/>
+            <a:off x="7772400" y="1783080"/>
+            <a:ext cx="3840480" cy="4343400"/>
           </a:xfrm>
           <a:prstGeom prst="roundRect">
             <a:avLst>
-              <a:gd name="adj" fmla="val 9677"/>
-            </a:avLst>
-          </a:prstGeom>
-          <a:solidFill>
-            <a:srgbClr val="F4F6F8"/>
-          </a:solidFill>
-          <a:ln w="9525">
-            <a:solidFill>
-              <a:srgbClr val="C9D1D9"/>
-            </a:solidFill>
-            <a:prstDash val="solid"/>
-          </a:ln>
-        </p:spPr>
-      </p:sp>
-      <p:sp>
-        <p:nvSpPr>
-          <p:cNvPr id="7" name="Text 5"/>
-          <p:cNvSpPr txBox="1"/>
-          <p:nvPr/>
-        </p:nvSpPr>
-        <p:spPr>
-          <a:xfrm>
-            <a:off x="822960" y="2414016"/>
-            <a:ext cx="566928" cy="713232"/>
-          </a:xfrm>
-          <a:prstGeom prst="rect">
-            <a:avLst/>
-          </a:prstGeom>
-          <a:noFill/>
-          <a:ln/>
-        </p:spPr>
-        <p:txBody>
-          <a:bodyPr wrap="square" lIns="0" tIns="0" rIns="0" bIns="0" rtlCol="0" anchor="ctr"/>
-          <a:lstStyle/>
-          <a:p>
-            <a:pPr algn="ctr" indent="0" marL="0">
-              <a:buNone/>
-            </a:pPr>
-            <a:r>
-              <a:rPr lang="en-US" sz="1500" b="1" dirty="0">
-                <a:solidFill>
-                  <a:srgbClr val="C8282E"/>
-                </a:solidFill>
-                <a:latin typeface="Arial" pitchFamily="34" charset="0"/>
-                <a:ea typeface="Arial" pitchFamily="34" charset="-122"/>
-                <a:cs typeface="Arial" pitchFamily="34" charset="-120"/>
-              </a:rPr>
-              <a:t>8</a:t>
-            </a:r>
-            <a:endParaRPr lang="en-US" sz="1500" dirty="0"/>
-          </a:p>
-          <a:p>
-            <a:pPr algn="ctr" indent="0" marL="0">
-              <a:buNone/>
-            </a:pPr>
-            <a:r>
-              <a:rPr lang="en-US" sz="1700" dirty="0">
-                <a:solidFill>
-                  <a:srgbClr val="C8282E"/>
-                </a:solidFill>
-                <a:latin typeface="Arial" pitchFamily="34" charset="0"/>
-                <a:ea typeface="Arial" pitchFamily="34" charset="-122"/>
-                <a:cs typeface="Arial" pitchFamily="34" charset="-120"/>
-              </a:rPr>
-              <a:t>♦</a:t>
-            </a:r>
-            <a:endParaRPr lang="en-US" sz="1500" dirty="0"/>
-          </a:p>
-        </p:txBody>
-      </p:sp>
-      <p:sp>
-        <p:nvSpPr>
-          <p:cNvPr id="8" name="card QD"/>
-          <p:cNvSpPr/>
-          <p:nvPr/>
-        </p:nvSpPr>
-        <p:spPr>
-          <a:xfrm>
-            <a:off x="1463040" y="2377440"/>
-            <a:ext cx="566928" cy="786384"/>
-          </a:xfrm>
-          <a:prstGeom prst="roundRect">
-            <a:avLst>
-              <a:gd name="adj" fmla="val 9677"/>
-            </a:avLst>
-          </a:prstGeom>
-          <a:solidFill>
-            <a:srgbClr val="F4F6F8"/>
-          </a:solidFill>
-          <a:ln w="28575">
-            <a:solidFill>
-              <a:srgbClr val="2DE2A6"/>
-            </a:solidFill>
-            <a:prstDash val="solid"/>
-          </a:ln>
-        </p:spPr>
-      </p:sp>
-      <p:sp>
-        <p:nvSpPr>
-          <p:cNvPr id="9" name="Text 7"/>
-          <p:cNvSpPr txBox="1"/>
-          <p:nvPr/>
-        </p:nvSpPr>
-        <p:spPr>
-          <a:xfrm>
-            <a:off x="1463040" y="2414016"/>
-            <a:ext cx="566928" cy="713232"/>
-          </a:xfrm>
-          <a:prstGeom prst="rect">
-            <a:avLst/>
-          </a:prstGeom>
-          <a:noFill/>
-          <a:ln/>
-        </p:spPr>
-        <p:txBody>
-          <a:bodyPr wrap="square" lIns="0" tIns="0" rIns="0" bIns="0" rtlCol="0" anchor="ctr"/>
-          <a:lstStyle/>
-          <a:p>
-            <a:pPr algn="ctr" indent="0" marL="0">
-              <a:buNone/>
-            </a:pPr>
-            <a:r>
-              <a:rPr lang="en-US" sz="1500" b="1" dirty="0">
-                <a:solidFill>
-                  <a:srgbClr val="C8282E"/>
-                </a:solidFill>
-                <a:latin typeface="Arial" pitchFamily="34" charset="0"/>
-                <a:ea typeface="Arial" pitchFamily="34" charset="-122"/>
-                <a:cs typeface="Arial" pitchFamily="34" charset="-120"/>
-              </a:rPr>
-              <a:t>Q</a:t>
-            </a:r>
-            <a:endParaRPr lang="en-US" sz="1500" dirty="0"/>
-          </a:p>
-          <a:p>
-            <a:pPr algn="ctr" indent="0" marL="0">
-              <a:buNone/>
-            </a:pPr>
-            <a:r>
-              <a:rPr lang="en-US" sz="1700" dirty="0">
-                <a:solidFill>
-                  <a:srgbClr val="C8282E"/>
-                </a:solidFill>
-                <a:latin typeface="Arial" pitchFamily="34" charset="0"/>
-                <a:ea typeface="Arial" pitchFamily="34" charset="-122"/>
-                <a:cs typeface="Arial" pitchFamily="34" charset="-120"/>
-              </a:rPr>
-              <a:t>♦</a:t>
-            </a:r>
-            <a:endParaRPr lang="en-US" sz="1500" dirty="0"/>
-          </a:p>
-        </p:txBody>
-      </p:sp>
-      <p:sp>
-        <p:nvSpPr>
-          <p:cNvPr id="10" name="card 10D"/>
-          <p:cNvSpPr/>
-          <p:nvPr/>
-        </p:nvSpPr>
-        <p:spPr>
-          <a:xfrm>
-            <a:off x="2103120" y="2377440"/>
-            <a:ext cx="566928" cy="786384"/>
-          </a:xfrm>
-          <a:prstGeom prst="roundRect">
-            <a:avLst>
-              <a:gd name="adj" fmla="val 9677"/>
-            </a:avLst>
-          </a:prstGeom>
-          <a:solidFill>
-            <a:srgbClr val="F4F6F8"/>
-          </a:solidFill>
-          <a:ln w="28575">
-            <a:solidFill>
-              <a:srgbClr val="2DE2A6"/>
-            </a:solidFill>
-            <a:prstDash val="solid"/>
-          </a:ln>
-        </p:spPr>
-      </p:sp>
-      <p:sp>
-        <p:nvSpPr>
-          <p:cNvPr id="11" name="Text 9"/>
-          <p:cNvSpPr txBox="1"/>
-          <p:nvPr/>
-        </p:nvSpPr>
-        <p:spPr>
-          <a:xfrm>
-            <a:off x="2103120" y="2414016"/>
-            <a:ext cx="566928" cy="713232"/>
-          </a:xfrm>
-          <a:prstGeom prst="rect">
-            <a:avLst/>
-          </a:prstGeom>
-          <a:noFill/>
-          <a:ln/>
-        </p:spPr>
-        <p:txBody>
-          <a:bodyPr wrap="square" lIns="0" tIns="0" rIns="0" bIns="0" rtlCol="0" anchor="ctr"/>
-          <a:lstStyle/>
-          <a:p>
-            <a:pPr algn="ctr" indent="0" marL="0">
-              <a:buNone/>
-            </a:pPr>
-            <a:r>
-              <a:rPr lang="en-US" sz="1500" b="1" dirty="0">
-                <a:solidFill>
-                  <a:srgbClr val="C8282E"/>
-                </a:solidFill>
-                <a:latin typeface="Arial" pitchFamily="34" charset="0"/>
-                <a:ea typeface="Arial" pitchFamily="34" charset="-122"/>
-                <a:cs typeface="Arial" pitchFamily="34" charset="-120"/>
-              </a:rPr>
-              <a:t>10</a:t>
-            </a:r>
-            <a:endParaRPr lang="en-US" sz="1500" dirty="0"/>
-          </a:p>
-          <a:p>
-            <a:pPr algn="ctr" indent="0" marL="0">
-              <a:buNone/>
-            </a:pPr>
-            <a:r>
-              <a:rPr lang="en-US" sz="1700" dirty="0">
-                <a:solidFill>
-                  <a:srgbClr val="C8282E"/>
-                </a:solidFill>
-                <a:latin typeface="Arial" pitchFamily="34" charset="0"/>
-                <a:ea typeface="Arial" pitchFamily="34" charset="-122"/>
-                <a:cs typeface="Arial" pitchFamily="34" charset="-120"/>
-              </a:rPr>
-              <a:t>♦</a:t>
-            </a:r>
-            <a:endParaRPr lang="en-US" sz="1500" dirty="0"/>
-          </a:p>
-        </p:txBody>
-      </p:sp>
-      <p:sp>
-        <p:nvSpPr>
-          <p:cNvPr id="12" name="card AD"/>
-          <p:cNvSpPr/>
-          <p:nvPr/>
-        </p:nvSpPr>
-        <p:spPr>
-          <a:xfrm>
-            <a:off x="2743200" y="2377440"/>
-            <a:ext cx="566928" cy="786384"/>
-          </a:xfrm>
-          <a:prstGeom prst="roundRect">
-            <a:avLst>
-              <a:gd name="adj" fmla="val 9677"/>
-            </a:avLst>
-          </a:prstGeom>
-          <a:solidFill>
-            <a:srgbClr val="F4F6F8"/>
-          </a:solidFill>
-          <a:ln w="28575">
-            <a:solidFill>
-              <a:srgbClr val="2DE2A6"/>
-            </a:solidFill>
-            <a:prstDash val="solid"/>
-          </a:ln>
-        </p:spPr>
-      </p:sp>
-      <p:sp>
-        <p:nvSpPr>
-          <p:cNvPr id="13" name="Text 11"/>
-          <p:cNvSpPr txBox="1"/>
-          <p:nvPr/>
-        </p:nvSpPr>
-        <p:spPr>
-          <a:xfrm>
-            <a:off x="2743200" y="2414016"/>
-            <a:ext cx="566928" cy="713232"/>
-          </a:xfrm>
-          <a:prstGeom prst="rect">
-            <a:avLst/>
-          </a:prstGeom>
-          <a:noFill/>
-          <a:ln/>
-        </p:spPr>
-        <p:txBody>
-          <a:bodyPr wrap="square" lIns="0" tIns="0" rIns="0" bIns="0" rtlCol="0" anchor="ctr"/>
-          <a:lstStyle/>
-          <a:p>
-            <a:pPr algn="ctr" indent="0" marL="0">
-              <a:buNone/>
-            </a:pPr>
-            <a:r>
-              <a:rPr lang="en-US" sz="1500" b="1" dirty="0">
-                <a:solidFill>
-                  <a:srgbClr val="C8282E"/>
-                </a:solidFill>
-                <a:latin typeface="Arial" pitchFamily="34" charset="0"/>
-                <a:ea typeface="Arial" pitchFamily="34" charset="-122"/>
-                <a:cs typeface="Arial" pitchFamily="34" charset="-120"/>
-              </a:rPr>
-              <a:t>A</a:t>
-            </a:r>
-            <a:endParaRPr lang="en-US" sz="1500" dirty="0"/>
-          </a:p>
-          <a:p>
-            <a:pPr algn="ctr" indent="0" marL="0">
-              <a:buNone/>
-            </a:pPr>
-            <a:r>
-              <a:rPr lang="en-US" sz="1700" dirty="0">
-                <a:solidFill>
-                  <a:srgbClr val="C8282E"/>
-                </a:solidFill>
-                <a:latin typeface="Arial" pitchFamily="34" charset="0"/>
-                <a:ea typeface="Arial" pitchFamily="34" charset="-122"/>
-                <a:cs typeface="Arial" pitchFamily="34" charset="-120"/>
-              </a:rPr>
-              <a:t>♦</a:t>
-            </a:r>
-            <a:endParaRPr lang="en-US" sz="1500" dirty="0"/>
-          </a:p>
-        </p:txBody>
-      </p:sp>
-      <p:sp>
-        <p:nvSpPr>
-          <p:cNvPr id="14" name="card 7S"/>
-          <p:cNvSpPr/>
-          <p:nvPr/>
-        </p:nvSpPr>
-        <p:spPr>
-          <a:xfrm>
-            <a:off x="3383280" y="2377440"/>
-            <a:ext cx="566928" cy="786384"/>
-          </a:xfrm>
-          <a:prstGeom prst="roundRect">
-            <a:avLst>
-              <a:gd name="adj" fmla="val 9677"/>
-            </a:avLst>
-          </a:prstGeom>
-          <a:solidFill>
-            <a:srgbClr val="F4F6F8"/>
-          </a:solidFill>
-          <a:ln w="9525">
-            <a:solidFill>
-              <a:srgbClr val="C9D1D9"/>
-            </a:solidFill>
-            <a:prstDash val="solid"/>
-          </a:ln>
-        </p:spPr>
-      </p:sp>
-      <p:sp>
-        <p:nvSpPr>
-          <p:cNvPr id="15" name="Text 13"/>
-          <p:cNvSpPr txBox="1"/>
-          <p:nvPr/>
-        </p:nvSpPr>
-        <p:spPr>
-          <a:xfrm>
-            <a:off x="3383280" y="2414016"/>
-            <a:ext cx="566928" cy="713232"/>
-          </a:xfrm>
-          <a:prstGeom prst="rect">
-            <a:avLst/>
-          </a:prstGeom>
-          <a:noFill/>
-          <a:ln/>
-        </p:spPr>
-        <p:txBody>
-          <a:bodyPr wrap="square" lIns="0" tIns="0" rIns="0" bIns="0" rtlCol="0" anchor="ctr"/>
-          <a:lstStyle/>
-          <a:p>
-            <a:pPr algn="ctr" indent="0" marL="0">
-              <a:buNone/>
-            </a:pPr>
-            <a:r>
-              <a:rPr lang="en-US" sz="1500" b="1" dirty="0">
-                <a:solidFill>
-                  <a:srgbClr val="11161C"/>
-                </a:solidFill>
-                <a:latin typeface="Arial" pitchFamily="34" charset="0"/>
-                <a:ea typeface="Arial" pitchFamily="34" charset="-122"/>
-                <a:cs typeface="Arial" pitchFamily="34" charset="-120"/>
-              </a:rPr>
-              <a:t>7</a:t>
-            </a:r>
-            <a:endParaRPr lang="en-US" sz="1500" dirty="0"/>
-          </a:p>
-          <a:p>
-            <a:pPr algn="ctr" indent="0" marL="0">
-              <a:buNone/>
-            </a:pPr>
-            <a:r>
-              <a:rPr lang="en-US" sz="1700" dirty="0">
-                <a:solidFill>
-                  <a:srgbClr val="11161C"/>
-                </a:solidFill>
-                <a:latin typeface="Arial" pitchFamily="34" charset="0"/>
-                <a:ea typeface="Arial" pitchFamily="34" charset="-122"/>
-                <a:cs typeface="Arial" pitchFamily="34" charset="-120"/>
-              </a:rPr>
-              <a:t>♠</a:t>
-            </a:r>
-            <a:endParaRPr lang="en-US" sz="1500" dirty="0"/>
-          </a:p>
-        </p:txBody>
-      </p:sp>
-      <p:sp>
-        <p:nvSpPr>
-          <p:cNvPr id="16" name="card 10H"/>
-          <p:cNvSpPr/>
-          <p:nvPr/>
-        </p:nvSpPr>
-        <p:spPr>
-          <a:xfrm>
-            <a:off x="4023360" y="2377440"/>
-            <a:ext cx="566928" cy="786384"/>
-          </a:xfrm>
-          <a:prstGeom prst="roundRect">
-            <a:avLst>
-              <a:gd name="adj" fmla="val 9677"/>
-            </a:avLst>
-          </a:prstGeom>
-          <a:solidFill>
-            <a:srgbClr val="F4F6F8"/>
-          </a:solidFill>
-          <a:ln w="9525">
-            <a:solidFill>
-              <a:srgbClr val="C9D1D9"/>
-            </a:solidFill>
-            <a:prstDash val="solid"/>
-          </a:ln>
-        </p:spPr>
-      </p:sp>
-      <p:sp>
-        <p:nvSpPr>
-          <p:cNvPr id="17" name="Text 15"/>
-          <p:cNvSpPr txBox="1"/>
-          <p:nvPr/>
-        </p:nvSpPr>
-        <p:spPr>
-          <a:xfrm>
-            <a:off x="4023360" y="2414016"/>
-            <a:ext cx="566928" cy="713232"/>
-          </a:xfrm>
-          <a:prstGeom prst="rect">
-            <a:avLst/>
-          </a:prstGeom>
-          <a:noFill/>
-          <a:ln/>
-        </p:spPr>
-        <p:txBody>
-          <a:bodyPr wrap="square" lIns="0" tIns="0" rIns="0" bIns="0" rtlCol="0" anchor="ctr"/>
-          <a:lstStyle/>
-          <a:p>
-            <a:pPr algn="ctr" indent="0" marL="0">
-              <a:buNone/>
-            </a:pPr>
-            <a:r>
-              <a:rPr lang="en-US" sz="1500" b="1" dirty="0">
-                <a:solidFill>
-                  <a:srgbClr val="C8282E"/>
-                </a:solidFill>
-                <a:latin typeface="Arial" pitchFamily="34" charset="0"/>
-                <a:ea typeface="Arial" pitchFamily="34" charset="-122"/>
-                <a:cs typeface="Arial" pitchFamily="34" charset="-120"/>
-              </a:rPr>
-              <a:t>10</a:t>
-            </a:r>
-            <a:endParaRPr lang="en-US" sz="1500" dirty="0"/>
-          </a:p>
-          <a:p>
-            <a:pPr algn="ctr" indent="0" marL="0">
-              <a:buNone/>
-            </a:pPr>
-            <a:r>
-              <a:rPr lang="en-US" sz="1700" dirty="0">
-                <a:solidFill>
-                  <a:srgbClr val="C8282E"/>
-                </a:solidFill>
-                <a:latin typeface="Arial" pitchFamily="34" charset="0"/>
-                <a:ea typeface="Arial" pitchFamily="34" charset="-122"/>
-                <a:cs typeface="Arial" pitchFamily="34" charset="-120"/>
-              </a:rPr>
-              <a:t>♥</a:t>
-            </a:r>
-            <a:endParaRPr lang="en-US" sz="1500" dirty="0"/>
-          </a:p>
-        </p:txBody>
-      </p:sp>
-      <p:sp>
-        <p:nvSpPr>
-          <p:cNvPr id="18" name="card KC"/>
-          <p:cNvSpPr/>
-          <p:nvPr/>
-        </p:nvSpPr>
-        <p:spPr>
-          <a:xfrm>
-            <a:off x="4663440" y="2377440"/>
-            <a:ext cx="566928" cy="786384"/>
-          </a:xfrm>
-          <a:prstGeom prst="roundRect">
-            <a:avLst>
-              <a:gd name="adj" fmla="val 9677"/>
-            </a:avLst>
-          </a:prstGeom>
-          <a:solidFill>
-            <a:srgbClr val="F4F6F8"/>
-          </a:solidFill>
-          <a:ln w="9525">
-            <a:solidFill>
-              <a:srgbClr val="C9D1D9"/>
-            </a:solidFill>
-            <a:prstDash val="solid"/>
-          </a:ln>
-        </p:spPr>
-      </p:sp>
-      <p:sp>
-        <p:nvSpPr>
-          <p:cNvPr id="19" name="Text 17"/>
-          <p:cNvSpPr txBox="1"/>
-          <p:nvPr/>
-        </p:nvSpPr>
-        <p:spPr>
-          <a:xfrm>
-            <a:off x="4663440" y="2414016"/>
-            <a:ext cx="566928" cy="713232"/>
-          </a:xfrm>
-          <a:prstGeom prst="rect">
-            <a:avLst/>
-          </a:prstGeom>
-          <a:noFill/>
-          <a:ln/>
-        </p:spPr>
-        <p:txBody>
-          <a:bodyPr wrap="square" lIns="0" tIns="0" rIns="0" bIns="0" rtlCol="0" anchor="ctr"/>
-          <a:lstStyle/>
-          <a:p>
-            <a:pPr algn="ctr" indent="0" marL="0">
-              <a:buNone/>
-            </a:pPr>
-            <a:r>
-              <a:rPr lang="en-US" sz="1500" b="1" dirty="0">
-                <a:solidFill>
-                  <a:srgbClr val="11161C"/>
-                </a:solidFill>
-                <a:latin typeface="Arial" pitchFamily="34" charset="0"/>
-                <a:ea typeface="Arial" pitchFamily="34" charset="-122"/>
-                <a:cs typeface="Arial" pitchFamily="34" charset="-120"/>
-              </a:rPr>
-              <a:t>K</a:t>
-            </a:r>
-            <a:endParaRPr lang="en-US" sz="1500" dirty="0"/>
-          </a:p>
-          <a:p>
-            <a:pPr algn="ctr" indent="0" marL="0">
-              <a:buNone/>
-            </a:pPr>
-            <a:r>
-              <a:rPr lang="en-US" sz="1700" dirty="0">
-                <a:solidFill>
-                  <a:srgbClr val="11161C"/>
-                </a:solidFill>
-                <a:latin typeface="Arial" pitchFamily="34" charset="0"/>
-                <a:ea typeface="Arial" pitchFamily="34" charset="-122"/>
-                <a:cs typeface="Arial" pitchFamily="34" charset="-120"/>
-              </a:rPr>
-              <a:t>♣</a:t>
-            </a:r>
-            <a:endParaRPr lang="en-US" sz="1500" dirty="0"/>
-          </a:p>
-        </p:txBody>
-      </p:sp>
-      <p:sp>
-        <p:nvSpPr>
-          <p:cNvPr id="20" name="card 10C"/>
-          <p:cNvSpPr/>
-          <p:nvPr/>
-        </p:nvSpPr>
-        <p:spPr>
-          <a:xfrm>
-            <a:off x="5303520" y="2377440"/>
-            <a:ext cx="566928" cy="786384"/>
-          </a:xfrm>
-          <a:prstGeom prst="roundRect">
-            <a:avLst>
-              <a:gd name="adj" fmla="val 9677"/>
-            </a:avLst>
-          </a:prstGeom>
-          <a:solidFill>
-            <a:srgbClr val="F4F6F8"/>
-          </a:solidFill>
-          <a:ln w="9525">
-            <a:solidFill>
-              <a:srgbClr val="C9D1D9"/>
-            </a:solidFill>
-            <a:prstDash val="solid"/>
-          </a:ln>
-        </p:spPr>
-      </p:sp>
-      <p:sp>
-        <p:nvSpPr>
-          <p:cNvPr id="21" name="Text 19"/>
-          <p:cNvSpPr txBox="1"/>
-          <p:nvPr/>
-        </p:nvSpPr>
-        <p:spPr>
-          <a:xfrm>
-            <a:off x="5303520" y="2414016"/>
-            <a:ext cx="566928" cy="713232"/>
-          </a:xfrm>
-          <a:prstGeom prst="rect">
-            <a:avLst/>
-          </a:prstGeom>
-          <a:noFill/>
-          <a:ln/>
-        </p:spPr>
-        <p:txBody>
-          <a:bodyPr wrap="square" lIns="0" tIns="0" rIns="0" bIns="0" rtlCol="0" anchor="ctr"/>
-          <a:lstStyle/>
-          <a:p>
-            <a:pPr algn="ctr" indent="0" marL="0">
-              <a:buNone/>
-            </a:pPr>
-            <a:r>
-              <a:rPr lang="en-US" sz="1500" b="1" dirty="0">
-                <a:solidFill>
-                  <a:srgbClr val="11161C"/>
-                </a:solidFill>
-                <a:latin typeface="Arial" pitchFamily="34" charset="0"/>
-                <a:ea typeface="Arial" pitchFamily="34" charset="-122"/>
-                <a:cs typeface="Arial" pitchFamily="34" charset="-120"/>
-              </a:rPr>
-              <a:t>10</a:t>
-            </a:r>
-            <a:endParaRPr lang="en-US" sz="1500" dirty="0"/>
-          </a:p>
-          <a:p>
-            <a:pPr algn="ctr" indent="0" marL="0">
-              <a:buNone/>
-            </a:pPr>
-            <a:r>
-              <a:rPr lang="en-US" sz="1700" dirty="0">
-                <a:solidFill>
-                  <a:srgbClr val="11161C"/>
-                </a:solidFill>
-                <a:latin typeface="Arial" pitchFamily="34" charset="0"/>
-                <a:ea typeface="Arial" pitchFamily="34" charset="-122"/>
-                <a:cs typeface="Arial" pitchFamily="34" charset="-120"/>
-              </a:rPr>
-              <a:t>♣</a:t>
-            </a:r>
-            <a:endParaRPr lang="en-US" sz="1500" dirty="0"/>
-          </a:p>
-        </p:txBody>
-      </p:sp>
-      <p:sp>
-        <p:nvSpPr>
-          <p:cNvPr id="22" name="Text 20"/>
-          <p:cNvSpPr txBox="1"/>
-          <p:nvPr/>
-        </p:nvSpPr>
-        <p:spPr>
-          <a:xfrm>
-            <a:off x="822960" y="3246120"/>
-            <a:ext cx="6400800" cy="320040"/>
-          </a:xfrm>
-          <a:prstGeom prst="rect">
-            <a:avLst/>
-          </a:prstGeom>
-          <a:noFill/>
-          <a:ln/>
-        </p:spPr>
-        <p:txBody>
-          <a:bodyPr wrap="square" lIns="0" tIns="0" rIns="0" bIns="0" rtlCol="0" anchor="t"/>
-          <a:lstStyle/>
-          <a:p>
-            <a:pPr indent="0" marL="0">
-              <a:buNone/>
-            </a:pPr>
-            <a:r>
-              <a:rPr lang="en-US" sz="1300" dirty="0">
-                <a:solidFill>
-                  <a:schemeClr val="tx2"/>
-                </a:solidFill>
-              </a:rPr>
-              <a:t>Big trumps — but not the Jack or the Nine, the opponent holds both.</a:t>
-            </a:r>
-            <a:endParaRPr lang="en-US" sz="1300" dirty="0"/>
-          </a:p>
-        </p:txBody>
-      </p:sp>
-      <p:sp>
-        <p:nvSpPr>
-          <p:cNvPr id="23" name="deal play 0"/>
-          <p:cNvSpPr/>
-          <p:nvPr/>
-        </p:nvSpPr>
-        <p:spPr>
-          <a:xfrm>
-            <a:off x="822960" y="3749040"/>
-            <a:ext cx="6400800" cy="914400"/>
-          </a:xfrm>
-          <a:prstGeom prst="roundRect">
-            <a:avLst>
-              <a:gd name="adj" fmla="val 6000"/>
-            </a:avLst>
-          </a:prstGeom>
-          <a:solidFill>
-            <a:schemeClr val="bg1"/>
-          </a:solidFill>
-          <a:ln w="12700">
-            <a:solidFill>
-              <a:schemeClr val="accent6"/>
-            </a:solidFill>
-            <a:prstDash val="solid"/>
-          </a:ln>
-        </p:spPr>
-      </p:sp>
-      <p:sp>
-        <p:nvSpPr>
-          <p:cNvPr id="24" name="Text 22"/>
-          <p:cNvSpPr txBox="1"/>
-          <p:nvPr/>
-        </p:nvSpPr>
-        <p:spPr>
-          <a:xfrm>
-            <a:off x="1005840" y="3840480"/>
-            <a:ext cx="1463040" cy="731520"/>
-          </a:xfrm>
-          <a:prstGeom prst="rect">
-            <a:avLst/>
-          </a:prstGeom>
-          <a:noFill/>
-          <a:ln/>
-        </p:spPr>
-        <p:txBody>
-          <a:bodyPr wrap="square" lIns="0" tIns="0" rIns="0" bIns="0" rtlCol="0" anchor="ctr"/>
-          <a:lstStyle/>
-          <a:p>
-            <a:pPr indent="0" marL="0">
-              <a:buNone/>
-            </a:pPr>
-            <a:r>
-              <a:rPr lang="en-US" sz="1400" b="1" dirty="0">
-                <a:solidFill>
-                  <a:schemeClr val="tx1"/>
-                </a:solidFill>
-              </a:rPr>
-              <a:t>TrumpCount</a:t>
-            </a:r>
-            <a:endParaRPr lang="en-US" sz="1400" dirty="0"/>
-          </a:p>
-        </p:txBody>
-      </p:sp>
-      <p:sp>
-        <p:nvSpPr>
-          <p:cNvPr id="25" name="Text 23"/>
-          <p:cNvSpPr txBox="1"/>
-          <p:nvPr/>
-        </p:nvSpPr>
-        <p:spPr>
-          <a:xfrm>
-            <a:off x="2468880" y="3840480"/>
-            <a:ext cx="3566160" cy="731520"/>
-          </a:xfrm>
-          <a:prstGeom prst="rect">
-            <a:avLst/>
-          </a:prstGeom>
-          <a:noFill/>
-          <a:ln/>
-        </p:spPr>
-        <p:txBody>
-          <a:bodyPr wrap="square" lIns="0" tIns="0" rIns="0" bIns="0" rtlCol="0" anchor="ctr"/>
-          <a:lstStyle/>
-          <a:p>
-            <a:pPr indent="0" marL="0">
-              <a:buNone/>
-            </a:pPr>
-            <a:r>
-              <a:rPr lang="en-US" sz="1200" dirty="0">
-                <a:solidFill>
-                  <a:schemeClr val="tx2"/>
-                </a:solidFill>
-              </a:rPr>
-              <a:t>Leads the Ace of trump at once → captured by the Jack (−31 pts).</a:t>
-            </a:r>
-            <a:endParaRPr lang="en-US" sz="1200" dirty="0"/>
-          </a:p>
-        </p:txBody>
-      </p:sp>
-      <p:sp>
-        <p:nvSpPr>
-          <p:cNvPr id="26" name="Text 24"/>
-          <p:cNvSpPr txBox="1"/>
-          <p:nvPr/>
-        </p:nvSpPr>
-        <p:spPr>
-          <a:xfrm>
-            <a:off x="6035040" y="3840480"/>
-            <a:ext cx="1097280" cy="731520"/>
-          </a:xfrm>
-          <a:prstGeom prst="rect">
-            <a:avLst/>
-          </a:prstGeom>
-          <a:noFill/>
-          <a:ln/>
-        </p:spPr>
-        <p:txBody>
-          <a:bodyPr wrap="square" lIns="0" tIns="0" rIns="0" bIns="0" rtlCol="0" anchor="ctr"/>
-          <a:lstStyle/>
-          <a:p>
-            <a:pPr algn="r" indent="0" marL="0">
-              <a:buNone/>
-            </a:pPr>
-            <a:r>
-              <a:rPr lang="en-US" sz="2400" b="1" dirty="0">
-                <a:solidFill>
-                  <a:schemeClr val="tx2"/>
-                </a:solidFill>
-                <a:latin typeface="Courier New" pitchFamily="34" charset="0"/>
-                <a:ea typeface="Courier New" pitchFamily="34" charset="-122"/>
-                <a:cs typeface="Courier New" pitchFamily="34" charset="-120"/>
-              </a:rPr>
-              <a:t>7</a:t>
-            </a:r>
-            <a:pPr algn="r" indent="0" marL="0">
-              <a:buNone/>
-            </a:pPr>
-            <a:r>
-              <a:rPr lang="en-US" sz="1100" dirty="0">
-                <a:solidFill>
-                  <a:schemeClr val="tx2"/>
-                </a:solidFill>
-                <a:latin typeface="Courier New" pitchFamily="34" charset="0"/>
-                <a:ea typeface="Courier New" pitchFamily="34" charset="-122"/>
-                <a:cs typeface="Courier New" pitchFamily="34" charset="-120"/>
-              </a:rPr>
-              <a:t> pts</a:t>
-            </a:r>
-            <a:endParaRPr lang="en-US" sz="2400" dirty="0"/>
-          </a:p>
-        </p:txBody>
-      </p:sp>
-      <p:sp>
-        <p:nvSpPr>
-          <p:cNvPr id="27" name="deal play 1"/>
-          <p:cNvSpPr/>
-          <p:nvPr/>
-        </p:nvSpPr>
-        <p:spPr>
-          <a:xfrm>
-            <a:off x="822960" y="4846320"/>
-            <a:ext cx="6400800" cy="914400"/>
-          </a:xfrm>
-          <a:prstGeom prst="roundRect">
-            <a:avLst>
-              <a:gd name="adj" fmla="val 6000"/>
-            </a:avLst>
-          </a:prstGeom>
-          <a:solidFill>
-            <a:schemeClr val="bg1"/>
-          </a:solidFill>
-          <a:ln w="12700">
-            <a:solidFill>
-              <a:schemeClr val="accent1"/>
-            </a:solidFill>
-            <a:prstDash val="solid"/>
-          </a:ln>
-        </p:spPr>
-      </p:sp>
-      <p:sp>
-        <p:nvSpPr>
-          <p:cNvPr id="28" name="Text 26"/>
-          <p:cNvSpPr txBox="1"/>
-          <p:nvPr/>
-        </p:nvSpPr>
-        <p:spPr>
-          <a:xfrm>
-            <a:off x="1005840" y="4937760"/>
-            <a:ext cx="1463040" cy="731520"/>
-          </a:xfrm>
-          <a:prstGeom prst="rect">
-            <a:avLst/>
-          </a:prstGeom>
-          <a:noFill/>
-          <a:ln/>
-        </p:spPr>
-        <p:txBody>
-          <a:bodyPr wrap="square" lIns="0" tIns="0" rIns="0" bIns="0" rtlCol="0" anchor="ctr"/>
-          <a:lstStyle/>
-          <a:p>
-            <a:pPr indent="0" marL="0">
-              <a:buNone/>
-            </a:pPr>
-            <a:r>
-              <a:rPr lang="en-US" sz="1400" b="1" dirty="0">
-                <a:solidFill>
-                  <a:schemeClr val="tx1"/>
-                </a:solidFill>
-              </a:rPr>
-              <a:t>PPO agent</a:t>
-            </a:r>
-            <a:endParaRPr lang="en-US" sz="1400" dirty="0"/>
-          </a:p>
-        </p:txBody>
-      </p:sp>
-      <p:sp>
-        <p:nvSpPr>
-          <p:cNvPr id="29" name="Text 27"/>
-          <p:cNvSpPr txBox="1"/>
-          <p:nvPr/>
-        </p:nvSpPr>
-        <p:spPr>
-          <a:xfrm>
-            <a:off x="2468880" y="4937760"/>
-            <a:ext cx="3566160" cy="731520"/>
-          </a:xfrm>
-          <a:prstGeom prst="rect">
-            <a:avLst/>
-          </a:prstGeom>
-          <a:noFill/>
-          <a:ln/>
-        </p:spPr>
-        <p:txBody>
-          <a:bodyPr wrap="square" lIns="0" tIns="0" rIns="0" bIns="0" rtlCol="0" anchor="ctr"/>
-          <a:lstStyle/>
-          <a:p>
-            <a:pPr indent="0" marL="0">
-              <a:buNone/>
-            </a:pPr>
-            <a:r>
-              <a:rPr lang="en-US" sz="1200" dirty="0">
-                <a:solidFill>
-                  <a:schemeClr val="tx2"/>
-                </a:solidFill>
-              </a:rPr>
-              <a:t>Ducks under the Jack with the 8, flushes out the Nine with the Queen, then cashes 10 + Ace as masters.</a:t>
-            </a:r>
-            <a:endParaRPr lang="en-US" sz="1200" dirty="0"/>
-          </a:p>
-        </p:txBody>
-      </p:sp>
-      <p:sp>
-        <p:nvSpPr>
-          <p:cNvPr id="30" name="Text 28"/>
-          <p:cNvSpPr txBox="1"/>
-          <p:nvPr/>
-        </p:nvSpPr>
-        <p:spPr>
-          <a:xfrm>
-            <a:off x="6035040" y="4937760"/>
-            <a:ext cx="1097280" cy="731520"/>
-          </a:xfrm>
-          <a:prstGeom prst="rect">
-            <a:avLst/>
-          </a:prstGeom>
-          <a:noFill/>
-          <a:ln/>
-        </p:spPr>
-        <p:txBody>
-          <a:bodyPr wrap="square" lIns="0" tIns="0" rIns="0" bIns="0" rtlCol="0" anchor="ctr"/>
-          <a:lstStyle/>
-          <a:p>
-            <a:pPr algn="r" indent="0" marL="0">
-              <a:buNone/>
-            </a:pPr>
-            <a:r>
-              <a:rPr lang="en-US" sz="2400" b="1" dirty="0">
-                <a:solidFill>
-                  <a:schemeClr val="accent1"/>
-                </a:solidFill>
-                <a:latin typeface="Courier New" pitchFamily="34" charset="0"/>
-                <a:ea typeface="Courier New" pitchFamily="34" charset="-122"/>
-                <a:cs typeface="Courier New" pitchFamily="34" charset="-120"/>
-              </a:rPr>
-              <a:t>58</a:t>
-            </a:r>
-            <a:pPr algn="r" indent="0" marL="0">
-              <a:buNone/>
-            </a:pPr>
-            <a:r>
-              <a:rPr lang="en-US" sz="1100" dirty="0">
-                <a:solidFill>
-                  <a:schemeClr val="tx2"/>
-                </a:solidFill>
-                <a:latin typeface="Courier New" pitchFamily="34" charset="0"/>
-                <a:ea typeface="Courier New" pitchFamily="34" charset="-122"/>
-                <a:cs typeface="Courier New" pitchFamily="34" charset="-120"/>
-              </a:rPr>
-              <a:t> pts</a:t>
-            </a:r>
-            <a:endParaRPr lang="en-US" sz="2400" dirty="0"/>
-          </a:p>
-        </p:txBody>
-      </p:sp>
-      <p:sp>
-        <p:nvSpPr>
-          <p:cNvPr id="31" name="learned card"/>
-          <p:cNvSpPr/>
-          <p:nvPr/>
-        </p:nvSpPr>
-        <p:spPr>
-          <a:xfrm>
-            <a:off x="7772400" y="1783080"/>
-            <a:ext cx="3840480" cy="2057400"/>
-          </a:xfrm>
-          <a:prstGeom prst="roundRect">
-            <a:avLst>
-              <a:gd name="adj" fmla="val 3556"/>
+              <a:gd name="adj" fmla="val 1905"/>
             </a:avLst>
           </a:prstGeom>
           <a:solidFill>
@@ -9598,7 +9014,7 @@
       </p:sp>
       <p:sp>
         <p:nvSpPr>
-          <p:cNvPr id="32" name="Text 30"/>
+          <p:cNvPr id="9" name="Text 6"/>
           <p:cNvSpPr txBox="1"/>
           <p:nvPr/>
         </p:nvSpPr>
@@ -9629,7 +9045,7 @@
                 <a:ea typeface="Courier New" pitchFamily="34" charset="-122"/>
                 <a:cs typeface="Courier New" pitchFamily="34" charset="-120"/>
               </a:rPr>
-              <a:t>LEARNED ALONE</a:t>
+              <a:t>TAKEAWAYS</a:t>
             </a:r>
             <a:endParaRPr lang="en-US" sz="1100" dirty="0"/>
           </a:p>
@@ -9637,14 +9053,14 @@
       </p:sp>
       <p:sp>
         <p:nvSpPr>
-          <p:cNvPr id="33" name="Text 31"/>
-          <p:cNvSpPr txBox="1"/>
-          <p:nvPr/>
-        </p:nvSpPr>
-        <p:spPr>
-          <a:xfrm>
-            <a:off x="8046720" y="2377440"/>
-            <a:ext cx="3383280" cy="1371600"/>
+          <p:cNvPr id="10" name="Text 7"/>
+          <p:cNvSpPr txBox="1"/>
+          <p:nvPr/>
+        </p:nvSpPr>
+        <p:spPr>
+          <a:xfrm>
+            <a:off x="8046720" y="2423160"/>
+            <a:ext cx="3383280" cy="3566160"/>
           </a:xfrm>
           <a:prstGeom prst="rect">
             <a:avLst/>
@@ -9656,174 +9072,107 @@
           <a:bodyPr wrap="square" lIns="0" tIns="0" rIns="0" bIns="0" rtlCol="0" anchor="t"/>
           <a:lstStyle/>
           <a:p>
-            <a:pPr marL="203200" indent="-203200">
-              <a:spcAft>
-                <a:spcPts val="800"/>
-              </a:spcAft>
-              <a:buSzPct val="100000"/>
-              <a:buChar char="•"/>
-            </a:pPr>
-            <a:r>
-              <a:rPr lang="en-US" sz="1300" dirty="0">
+            <a:pPr indent="0" marL="0">
+              <a:buNone/>
+            </a:pPr>
+            <a:r>
+              <a:rPr lang="en-US" sz="1400" b="1" dirty="0">
                 <a:solidFill>
                   <a:schemeClr val="tx1"/>
                 </a:solidFill>
               </a:rPr>
-              <a:t>Wait for the opponent's top trumps to fall</a:t>
-            </a:r>
-            <a:endParaRPr lang="en-US" sz="1500" dirty="0"/>
-          </a:p>
-          <a:p>
-            <a:pPr marL="203200" indent="-203200">
-              <a:spcAft>
-                <a:spcPts val="800"/>
-              </a:spcAft>
-              <a:buSzPct val="100000"/>
-              <a:buChar char="•"/>
-            </a:pPr>
-            <a:r>
-              <a:rPr lang="en-US" sz="1300" dirty="0">
+              <a:t>It improves against itself, </a:t>
+            </a:r>
+            <a:pPr indent="0" marL="0">
+              <a:buNone/>
+            </a:pPr>
+            <a:r>
+              <a:rPr lang="en-US" sz="1400" dirty="0">
                 <a:solidFill>
                   <a:schemeClr val="tx1"/>
                 </a:solidFill>
               </a:rPr>
-              <a:t>Profitable ruffs</a:t>
-            </a:r>
-            <a:endParaRPr lang="en-US" sz="1500" dirty="0"/>
-          </a:p>
-          <a:p>
-            <a:pPr marL="203200" indent="-203200">
-              <a:spcAft>
-                <a:spcPts val="800"/>
-              </a:spcAft>
-              <a:buSzPct val="100000"/>
-              <a:buChar char="•"/>
-            </a:pPr>
-            <a:r>
-              <a:rPr lang="en-US" sz="1300" dirty="0">
+              <a:t>not only against our heuristics.</a:t>
+            </a:r>
+            <a:endParaRPr lang="en-US" sz="1400" dirty="0"/>
+          </a:p>
+          <a:p>
+            <a:pPr indent="0" marL="0">
+              <a:buNone/>
+            </a:pPr>
+            <a:r>
+              <a:rPr lang="en-US" sz="800" dirty="0">
                 <a:solidFill>
                   <a:schemeClr val="tx1"/>
                 </a:solidFill>
               </a:rPr>
-              <a:t>Cash master cards at the end</a:t>
-            </a:r>
-            <a:endParaRPr lang="en-US" sz="1500" dirty="0"/>
-          </a:p>
-        </p:txBody>
-      </p:sp>
-      <p:sp>
-        <p:nvSpPr>
-          <p:cNvPr id="34" name="mistake card"/>
-          <p:cNvSpPr/>
-          <p:nvPr/>
-        </p:nvSpPr>
-        <p:spPr>
-          <a:xfrm>
-            <a:off x="7772400" y="4069080"/>
-            <a:ext cx="3840480" cy="2057400"/>
-          </a:xfrm>
-          <a:prstGeom prst="roundRect">
-            <a:avLst>
-              <a:gd name="adj" fmla="val 3556"/>
-            </a:avLst>
-          </a:prstGeom>
-          <a:solidFill>
-            <a:schemeClr val="bg2"/>
-          </a:solidFill>
-          <a:ln w="9525">
-            <a:solidFill>
-              <a:schemeClr val="accent6"/>
-            </a:solidFill>
-            <a:prstDash val="solid"/>
-          </a:ln>
-        </p:spPr>
-      </p:sp>
-      <p:sp>
-        <p:nvSpPr>
-          <p:cNvPr id="35" name="Text 33"/>
-          <p:cNvSpPr txBox="1"/>
-          <p:nvPr/>
-        </p:nvSpPr>
-        <p:spPr>
-          <a:xfrm>
-            <a:off x="8046720" y="4297680"/>
-            <a:ext cx="6400800" cy="274320"/>
-          </a:xfrm>
-          <a:prstGeom prst="rect">
-            <a:avLst/>
-          </a:prstGeom>
-          <a:noFill/>
-          <a:ln/>
-        </p:spPr>
-        <p:txBody>
-          <a:bodyPr wrap="square" lIns="0" tIns="0" rIns="0" bIns="0" rtlCol="0" anchor="ctr"/>
-          <a:lstStyle/>
+              <a:t> </a:t>
+            </a:r>
+            <a:endParaRPr lang="en-US" sz="1400" dirty="0"/>
+          </a:p>
           <a:p>
             <a:pPr indent="0" marL="0">
               <a:buNone/>
             </a:pPr>
             <a:r>
-              <a:rPr lang="en-US" sz="1100" b="1" dirty="0">
-                <a:solidFill>
-                  <a:schemeClr val="accent2"/>
-                </a:solidFill>
-                <a:latin typeface="Courier New" pitchFamily="34" charset="0"/>
-                <a:ea typeface="Courier New" pitchFamily="34" charset="-122"/>
-                <a:cs typeface="Courier New" pitchFamily="34" charset="-120"/>
-              </a:rPr>
-              <a:t>STILL WRONG</a:t>
-            </a:r>
-            <a:endParaRPr lang="en-US" sz="1100" dirty="0"/>
-          </a:p>
-        </p:txBody>
-      </p:sp>
-      <p:sp>
-        <p:nvSpPr>
-          <p:cNvPr id="36" name="Text 34"/>
-          <p:cNvSpPr txBox="1"/>
-          <p:nvPr/>
-        </p:nvSpPr>
-        <p:spPr>
-          <a:xfrm>
-            <a:off x="8046720" y="4663440"/>
-            <a:ext cx="3383280" cy="1371600"/>
-          </a:xfrm>
-          <a:prstGeom prst="rect">
-            <a:avLst/>
-          </a:prstGeom>
-          <a:noFill/>
-          <a:ln/>
-        </p:spPr>
-        <p:txBody>
-          <a:bodyPr wrap="square" lIns="0" tIns="0" rIns="0" bIns="0" rtlCol="0" anchor="t"/>
-          <a:lstStyle/>
-          <a:p>
+              <a:rPr lang="en-US" sz="1400" b="1" dirty="0">
+                <a:solidFill>
+                  <a:schemeClr val="tx1"/>
+                </a:solidFill>
+              </a:rPr>
+              <a:t>Gains shrink, then stop near 1.5–2M games: </a:t>
+            </a:r>
             <a:pPr indent="0" marL="0">
               <a:buNone/>
             </a:pPr>
             <a:r>
-              <a:rPr lang="en-US" sz="1300" dirty="0">
+              <a:rPr lang="en-US" sz="1400" dirty="0">
                 <a:solidFill>
                   <a:schemeClr val="tx1"/>
                 </a:solidFill>
               </a:rPr>
-              <a:t>Leads a Ten while the Ace is still out (−21 pts), with 100% confidence.</a:t>
-            </a:r>
-            <a:endParaRPr lang="en-US" sz="1300" dirty="0"/>
+              <a:t>the last million added nothing.</a:t>
+            </a:r>
+            <a:endParaRPr lang="en-US" sz="1400" dirty="0"/>
           </a:p>
           <a:p>
             <a:pPr indent="0" marL="0">
               <a:buNone/>
             </a:pPr>
             <a:r>
-              <a:rPr lang="en-US" sz="1300" b="1" dirty="0">
+              <a:rPr lang="en-US" sz="800" dirty="0">
+                <a:solidFill>
+                  <a:schemeClr val="tx1"/>
+                </a:solidFill>
+              </a:rPr>
+              <a:t> </a:t>
+            </a:r>
+            <a:endParaRPr lang="en-US" sz="1400" dirty="0"/>
+          </a:p>
+          <a:p>
+            <a:pPr indent="0" marL="0">
+              <a:buNone/>
+            </a:pPr>
+            <a:r>
+              <a:rPr lang="en-US" sz="1400" b="1" dirty="0">
                 <a:solidFill>
                   <a:schemeClr val="accent1"/>
                 </a:solidFill>
               </a:rPr>
-              <a:t>→ weak memory of which high cards remain.</a:t>
-            </a:r>
-            <a:endParaRPr lang="en-US" sz="1300" dirty="0"/>
+              <a:t>Going further needs a better agent </a:t>
+            </a:r>
+            <a:pPr indent="0" marL="0">
+              <a:buNone/>
+            </a:pPr>
+            <a:r>
+              <a:rPr lang="en-US" sz="1400" dirty="0">
+                <a:solidFill>
+                  <a:schemeClr val="tx1"/>
+                </a:solidFill>
+              </a:rPr>
+              <a:t>(memory, bigger net, league self-play), not longer training.</a:t>
+            </a:r>
+            <a:endParaRPr lang="en-US" sz="1400" dirty="0"/>
           </a:p>
         </p:txBody>
       </p:sp>
@@ -9935,7 +9284,7 @@
                 <a:ea typeface="Courier New" pitchFamily="34" charset="-122"/>
                 <a:cs typeface="Courier New" pitchFamily="34" charset="-120"/>
               </a:rPr>
-              <a:t>15 / NEXT STEPS</a:t>
+              <a:t>15 / BEHAVIOUR</a:t>
             </a:r>
             <a:endParaRPr lang="en-US" sz="1200" dirty="0"/>
           </a:p>
@@ -9973,7 +9322,7 @@
                   <a:schemeClr val="tx1"/>
                 </a:solidFill>
               </a:rPr>
-              <a:t>Where we stand — and what comes next</a:t>
+              <a:t>What the agent learned on its own</a:t>
             </a:r>
             <a:endParaRPr lang="en-US" sz="3400" dirty="0"/>
           </a:p>
@@ -9981,14 +9330,14 @@
       </p:sp>
       <p:sp>
         <p:nvSpPr>
-          <p:cNvPr id="4" name="done card"/>
+          <p:cNvPr id="4" name="good deal card"/>
           <p:cNvSpPr/>
           <p:nvPr/>
         </p:nvSpPr>
         <p:spPr>
           <a:xfrm>
             <a:off x="548640" y="1783080"/>
-            <a:ext cx="5394960" cy="4343400"/>
+            <a:ext cx="6949440" cy="4343400"/>
           </a:xfrm>
           <a:prstGeom prst="roundRect">
             <a:avLst>
@@ -10039,7 +9388,7 @@
                 <a:ea typeface="Courier New" pitchFamily="34" charset="-122"/>
                 <a:cs typeface="Courier New" pitchFamily="34" charset="-120"/>
               </a:rPr>
-              <a:t>DONE</a:t>
+              <a:t>SAME HAND, TWO PLAYERS · TRUMP ♦</a:t>
             </a:r>
             <a:endParaRPr lang="en-US" sz="1100" dirty="0"/>
           </a:p>
@@ -10047,130 +9396,1022 @@
       </p:sp>
       <p:sp>
         <p:nvSpPr>
-          <p:cNvPr id="6" name="Text 4"/>
-          <p:cNvSpPr txBox="1"/>
-          <p:nvPr/>
-        </p:nvSpPr>
-        <p:spPr>
-          <a:xfrm>
-            <a:off x="822960" y="2423160"/>
-            <a:ext cx="4937760" cy="3566160"/>
-          </a:xfrm>
-          <a:prstGeom prst="rect">
-            <a:avLst/>
-          </a:prstGeom>
-          <a:noFill/>
-          <a:ln/>
-        </p:spPr>
-        <p:txBody>
-          <a:bodyPr wrap="square" lIns="0" tIns="0" rIns="0" bIns="0" rtlCol="0" anchor="t"/>
-          <a:lstStyle/>
-          <a:p>
-            <a:pPr marL="203200" indent="-203200">
-              <a:spcAft>
-                <a:spcPts val="800"/>
-              </a:spcAft>
-              <a:buSzPct val="100000"/>
-              <a:buChar char="•"/>
-            </a:pPr>
-            <a:r>
-              <a:rPr lang="en-US" sz="1400" dirty="0">
-                <a:solidFill>
-                  <a:schemeClr val="tx1"/>
-                </a:solidFill>
-              </a:rPr>
-              <a:t>Tested Belote environment, 4 baselines, PPO from scratch</a:t>
-            </a:r>
-            <a:endParaRPr lang="en-US" sz="1500" dirty="0"/>
-          </a:p>
-          <a:p>
-            <a:pPr marL="203200" indent="-203200">
-              <a:spcAft>
-                <a:spcPts val="800"/>
-              </a:spcAft>
-              <a:buSzPct val="100000"/>
-              <a:buChar char="•"/>
-            </a:pPr>
-            <a:r>
-              <a:rPr lang="en-US" sz="1400" dirty="0">
-                <a:solidFill>
-                  <a:schemeClr val="tx1"/>
-                </a:solidFill>
-              </a:rPr>
-              <a:t>Duplicate-deal evaluation: 2–3× tighter error bars</a:t>
-            </a:r>
-            <a:endParaRPr lang="en-US" sz="1500" dirty="0"/>
-          </a:p>
-          <a:p>
-            <a:pPr marL="203200" indent="-203200">
-              <a:spcAft>
-                <a:spcPts val="800"/>
-              </a:spcAft>
-              <a:buSzPct val="100000"/>
-              <a:buChar char="•"/>
-            </a:pPr>
-            <a:r>
-              <a:rPr lang="en-US" sz="1400" dirty="0">
-                <a:solidFill>
-                  <a:schemeClr val="tx1"/>
-                </a:solidFill>
-              </a:rPr>
-              <a:t>Fixed 2 silent bugs (perspective leak, GAE across seats)</a:t>
-            </a:r>
-            <a:endParaRPr lang="en-US" sz="1500" dirty="0"/>
-          </a:p>
-          <a:p>
-            <a:pPr marL="203200" indent="-203200">
-              <a:spcAft>
-                <a:spcPts val="800"/>
-              </a:spcAft>
-              <a:buSzPct val="100000"/>
-              <a:buChar char="•"/>
-            </a:pPr>
-            <a:r>
-              <a:rPr lang="en-US" sz="1400" dirty="0">
-                <a:solidFill>
-                  <a:schemeClr val="tx1"/>
-                </a:solidFill>
-              </a:rPr>
-              <a:t>Ablations: removing the win bonus is the key change</a:t>
-            </a:r>
-            <a:endParaRPr lang="en-US" sz="1500" dirty="0"/>
-          </a:p>
-          <a:p>
-            <a:pPr marL="203200" indent="-203200">
-              <a:spcAft>
-                <a:spcPts val="800"/>
-              </a:spcAft>
-              <a:buSzPct val="100000"/>
-              <a:buChar char="•"/>
-            </a:pPr>
-            <a:r>
-              <a:rPr lang="en-US" sz="1400" dirty="0">
-                <a:solidFill>
-                  <a:schemeClr val="tx1"/>
-                </a:solidFill>
-              </a:rPr>
-              <a:t>3M games: +5.0 pts / 56% wins vs our best heuristic</a:t>
-            </a:r>
-            <a:endParaRPr lang="en-US" sz="1500" dirty="0"/>
-          </a:p>
-        </p:txBody>
-      </p:sp>
-      <p:sp>
-        <p:nvSpPr>
-          <p:cNvPr id="7" name="next card"/>
+          <p:cNvPr id="6" name="card 8D"/>
           <p:cNvSpPr/>
           <p:nvPr/>
         </p:nvSpPr>
         <p:spPr>
           <a:xfrm>
-            <a:off x="6217920" y="1783080"/>
-            <a:ext cx="5394960" cy="4343400"/>
+            <a:off x="822960" y="2377440"/>
+            <a:ext cx="566928" cy="786384"/>
           </a:xfrm>
           <a:prstGeom prst="roundRect">
             <a:avLst>
-              <a:gd name="adj" fmla="val 1684"/>
+              <a:gd name="adj" fmla="val 9677"/>
+            </a:avLst>
+          </a:prstGeom>
+          <a:solidFill>
+            <a:srgbClr val="F4F6F8"/>
+          </a:solidFill>
+          <a:ln w="9525">
+            <a:solidFill>
+              <a:srgbClr val="C9D1D9"/>
+            </a:solidFill>
+            <a:prstDash val="solid"/>
+          </a:ln>
+        </p:spPr>
+      </p:sp>
+      <p:sp>
+        <p:nvSpPr>
+          <p:cNvPr id="7" name="Text 5"/>
+          <p:cNvSpPr txBox="1"/>
+          <p:nvPr/>
+        </p:nvSpPr>
+        <p:spPr>
+          <a:xfrm>
+            <a:off x="822960" y="2414016"/>
+            <a:ext cx="566928" cy="713232"/>
+          </a:xfrm>
+          <a:prstGeom prst="rect">
+            <a:avLst/>
+          </a:prstGeom>
+          <a:noFill/>
+          <a:ln/>
+        </p:spPr>
+        <p:txBody>
+          <a:bodyPr wrap="square" lIns="0" tIns="0" rIns="0" bIns="0" rtlCol="0" anchor="ctr"/>
+          <a:lstStyle/>
+          <a:p>
+            <a:pPr algn="ctr" indent="0" marL="0">
+              <a:buNone/>
+            </a:pPr>
+            <a:r>
+              <a:rPr lang="en-US" sz="1500" b="1" dirty="0">
+                <a:solidFill>
+                  <a:srgbClr val="C8282E"/>
+                </a:solidFill>
+                <a:latin typeface="Arial" pitchFamily="34" charset="0"/>
+                <a:ea typeface="Arial" pitchFamily="34" charset="-122"/>
+                <a:cs typeface="Arial" pitchFamily="34" charset="-120"/>
+              </a:rPr>
+              <a:t>8</a:t>
+            </a:r>
+            <a:endParaRPr lang="en-US" sz="1500" dirty="0"/>
+          </a:p>
+          <a:p>
+            <a:pPr algn="ctr" indent="0" marL="0">
+              <a:buNone/>
+            </a:pPr>
+            <a:r>
+              <a:rPr lang="en-US" sz="1700" dirty="0">
+                <a:solidFill>
+                  <a:srgbClr val="C8282E"/>
+                </a:solidFill>
+                <a:latin typeface="Arial" pitchFamily="34" charset="0"/>
+                <a:ea typeface="Arial" pitchFamily="34" charset="-122"/>
+                <a:cs typeface="Arial" pitchFamily="34" charset="-120"/>
+              </a:rPr>
+              <a:t>♦</a:t>
+            </a:r>
+            <a:endParaRPr lang="en-US" sz="1500" dirty="0"/>
+          </a:p>
+        </p:txBody>
+      </p:sp>
+      <p:sp>
+        <p:nvSpPr>
+          <p:cNvPr id="8" name="card QD"/>
+          <p:cNvSpPr/>
+          <p:nvPr/>
+        </p:nvSpPr>
+        <p:spPr>
+          <a:xfrm>
+            <a:off x="1463040" y="2377440"/>
+            <a:ext cx="566928" cy="786384"/>
+          </a:xfrm>
+          <a:prstGeom prst="roundRect">
+            <a:avLst>
+              <a:gd name="adj" fmla="val 9677"/>
+            </a:avLst>
+          </a:prstGeom>
+          <a:solidFill>
+            <a:srgbClr val="F4F6F8"/>
+          </a:solidFill>
+          <a:ln w="28575">
+            <a:solidFill>
+              <a:srgbClr val="2DE2A6"/>
+            </a:solidFill>
+            <a:prstDash val="solid"/>
+          </a:ln>
+        </p:spPr>
+      </p:sp>
+      <p:sp>
+        <p:nvSpPr>
+          <p:cNvPr id="9" name="Text 7"/>
+          <p:cNvSpPr txBox="1"/>
+          <p:nvPr/>
+        </p:nvSpPr>
+        <p:spPr>
+          <a:xfrm>
+            <a:off x="1463040" y="2414016"/>
+            <a:ext cx="566928" cy="713232"/>
+          </a:xfrm>
+          <a:prstGeom prst="rect">
+            <a:avLst/>
+          </a:prstGeom>
+          <a:noFill/>
+          <a:ln/>
+        </p:spPr>
+        <p:txBody>
+          <a:bodyPr wrap="square" lIns="0" tIns="0" rIns="0" bIns="0" rtlCol="0" anchor="ctr"/>
+          <a:lstStyle/>
+          <a:p>
+            <a:pPr algn="ctr" indent="0" marL="0">
+              <a:buNone/>
+            </a:pPr>
+            <a:r>
+              <a:rPr lang="en-US" sz="1500" b="1" dirty="0">
+                <a:solidFill>
+                  <a:srgbClr val="C8282E"/>
+                </a:solidFill>
+                <a:latin typeface="Arial" pitchFamily="34" charset="0"/>
+                <a:ea typeface="Arial" pitchFamily="34" charset="-122"/>
+                <a:cs typeface="Arial" pitchFamily="34" charset="-120"/>
+              </a:rPr>
+              <a:t>Q</a:t>
+            </a:r>
+            <a:endParaRPr lang="en-US" sz="1500" dirty="0"/>
+          </a:p>
+          <a:p>
+            <a:pPr algn="ctr" indent="0" marL="0">
+              <a:buNone/>
+            </a:pPr>
+            <a:r>
+              <a:rPr lang="en-US" sz="1700" dirty="0">
+                <a:solidFill>
+                  <a:srgbClr val="C8282E"/>
+                </a:solidFill>
+                <a:latin typeface="Arial" pitchFamily="34" charset="0"/>
+                <a:ea typeface="Arial" pitchFamily="34" charset="-122"/>
+                <a:cs typeface="Arial" pitchFamily="34" charset="-120"/>
+              </a:rPr>
+              <a:t>♦</a:t>
+            </a:r>
+            <a:endParaRPr lang="en-US" sz="1500" dirty="0"/>
+          </a:p>
+        </p:txBody>
+      </p:sp>
+      <p:sp>
+        <p:nvSpPr>
+          <p:cNvPr id="10" name="card 10D"/>
+          <p:cNvSpPr/>
+          <p:nvPr/>
+        </p:nvSpPr>
+        <p:spPr>
+          <a:xfrm>
+            <a:off x="2103120" y="2377440"/>
+            <a:ext cx="566928" cy="786384"/>
+          </a:xfrm>
+          <a:prstGeom prst="roundRect">
+            <a:avLst>
+              <a:gd name="adj" fmla="val 9677"/>
+            </a:avLst>
+          </a:prstGeom>
+          <a:solidFill>
+            <a:srgbClr val="F4F6F8"/>
+          </a:solidFill>
+          <a:ln w="28575">
+            <a:solidFill>
+              <a:srgbClr val="2DE2A6"/>
+            </a:solidFill>
+            <a:prstDash val="solid"/>
+          </a:ln>
+        </p:spPr>
+      </p:sp>
+      <p:sp>
+        <p:nvSpPr>
+          <p:cNvPr id="11" name="Text 9"/>
+          <p:cNvSpPr txBox="1"/>
+          <p:nvPr/>
+        </p:nvSpPr>
+        <p:spPr>
+          <a:xfrm>
+            <a:off x="2103120" y="2414016"/>
+            <a:ext cx="566928" cy="713232"/>
+          </a:xfrm>
+          <a:prstGeom prst="rect">
+            <a:avLst/>
+          </a:prstGeom>
+          <a:noFill/>
+          <a:ln/>
+        </p:spPr>
+        <p:txBody>
+          <a:bodyPr wrap="square" lIns="0" tIns="0" rIns="0" bIns="0" rtlCol="0" anchor="ctr"/>
+          <a:lstStyle/>
+          <a:p>
+            <a:pPr algn="ctr" indent="0" marL="0">
+              <a:buNone/>
+            </a:pPr>
+            <a:r>
+              <a:rPr lang="en-US" sz="1500" b="1" dirty="0">
+                <a:solidFill>
+                  <a:srgbClr val="C8282E"/>
+                </a:solidFill>
+                <a:latin typeface="Arial" pitchFamily="34" charset="0"/>
+                <a:ea typeface="Arial" pitchFamily="34" charset="-122"/>
+                <a:cs typeface="Arial" pitchFamily="34" charset="-120"/>
+              </a:rPr>
+              <a:t>10</a:t>
+            </a:r>
+            <a:endParaRPr lang="en-US" sz="1500" dirty="0"/>
+          </a:p>
+          <a:p>
+            <a:pPr algn="ctr" indent="0" marL="0">
+              <a:buNone/>
+            </a:pPr>
+            <a:r>
+              <a:rPr lang="en-US" sz="1700" dirty="0">
+                <a:solidFill>
+                  <a:srgbClr val="C8282E"/>
+                </a:solidFill>
+                <a:latin typeface="Arial" pitchFamily="34" charset="0"/>
+                <a:ea typeface="Arial" pitchFamily="34" charset="-122"/>
+                <a:cs typeface="Arial" pitchFamily="34" charset="-120"/>
+              </a:rPr>
+              <a:t>♦</a:t>
+            </a:r>
+            <a:endParaRPr lang="en-US" sz="1500" dirty="0"/>
+          </a:p>
+        </p:txBody>
+      </p:sp>
+      <p:sp>
+        <p:nvSpPr>
+          <p:cNvPr id="12" name="card AD"/>
+          <p:cNvSpPr/>
+          <p:nvPr/>
+        </p:nvSpPr>
+        <p:spPr>
+          <a:xfrm>
+            <a:off x="2743200" y="2377440"/>
+            <a:ext cx="566928" cy="786384"/>
+          </a:xfrm>
+          <a:prstGeom prst="roundRect">
+            <a:avLst>
+              <a:gd name="adj" fmla="val 9677"/>
+            </a:avLst>
+          </a:prstGeom>
+          <a:solidFill>
+            <a:srgbClr val="F4F6F8"/>
+          </a:solidFill>
+          <a:ln w="28575">
+            <a:solidFill>
+              <a:srgbClr val="2DE2A6"/>
+            </a:solidFill>
+            <a:prstDash val="solid"/>
+          </a:ln>
+        </p:spPr>
+      </p:sp>
+      <p:sp>
+        <p:nvSpPr>
+          <p:cNvPr id="13" name="Text 11"/>
+          <p:cNvSpPr txBox="1"/>
+          <p:nvPr/>
+        </p:nvSpPr>
+        <p:spPr>
+          <a:xfrm>
+            <a:off x="2743200" y="2414016"/>
+            <a:ext cx="566928" cy="713232"/>
+          </a:xfrm>
+          <a:prstGeom prst="rect">
+            <a:avLst/>
+          </a:prstGeom>
+          <a:noFill/>
+          <a:ln/>
+        </p:spPr>
+        <p:txBody>
+          <a:bodyPr wrap="square" lIns="0" tIns="0" rIns="0" bIns="0" rtlCol="0" anchor="ctr"/>
+          <a:lstStyle/>
+          <a:p>
+            <a:pPr algn="ctr" indent="0" marL="0">
+              <a:buNone/>
+            </a:pPr>
+            <a:r>
+              <a:rPr lang="en-US" sz="1500" b="1" dirty="0">
+                <a:solidFill>
+                  <a:srgbClr val="C8282E"/>
+                </a:solidFill>
+                <a:latin typeface="Arial" pitchFamily="34" charset="0"/>
+                <a:ea typeface="Arial" pitchFamily="34" charset="-122"/>
+                <a:cs typeface="Arial" pitchFamily="34" charset="-120"/>
+              </a:rPr>
+              <a:t>A</a:t>
+            </a:r>
+            <a:endParaRPr lang="en-US" sz="1500" dirty="0"/>
+          </a:p>
+          <a:p>
+            <a:pPr algn="ctr" indent="0" marL="0">
+              <a:buNone/>
+            </a:pPr>
+            <a:r>
+              <a:rPr lang="en-US" sz="1700" dirty="0">
+                <a:solidFill>
+                  <a:srgbClr val="C8282E"/>
+                </a:solidFill>
+                <a:latin typeface="Arial" pitchFamily="34" charset="0"/>
+                <a:ea typeface="Arial" pitchFamily="34" charset="-122"/>
+                <a:cs typeface="Arial" pitchFamily="34" charset="-120"/>
+              </a:rPr>
+              <a:t>♦</a:t>
+            </a:r>
+            <a:endParaRPr lang="en-US" sz="1500" dirty="0"/>
+          </a:p>
+        </p:txBody>
+      </p:sp>
+      <p:sp>
+        <p:nvSpPr>
+          <p:cNvPr id="14" name="card 7S"/>
+          <p:cNvSpPr/>
+          <p:nvPr/>
+        </p:nvSpPr>
+        <p:spPr>
+          <a:xfrm>
+            <a:off x="3383280" y="2377440"/>
+            <a:ext cx="566928" cy="786384"/>
+          </a:xfrm>
+          <a:prstGeom prst="roundRect">
+            <a:avLst>
+              <a:gd name="adj" fmla="val 9677"/>
+            </a:avLst>
+          </a:prstGeom>
+          <a:solidFill>
+            <a:srgbClr val="F4F6F8"/>
+          </a:solidFill>
+          <a:ln w="9525">
+            <a:solidFill>
+              <a:srgbClr val="C9D1D9"/>
+            </a:solidFill>
+            <a:prstDash val="solid"/>
+          </a:ln>
+        </p:spPr>
+      </p:sp>
+      <p:sp>
+        <p:nvSpPr>
+          <p:cNvPr id="15" name="Text 13"/>
+          <p:cNvSpPr txBox="1"/>
+          <p:nvPr/>
+        </p:nvSpPr>
+        <p:spPr>
+          <a:xfrm>
+            <a:off x="3383280" y="2414016"/>
+            <a:ext cx="566928" cy="713232"/>
+          </a:xfrm>
+          <a:prstGeom prst="rect">
+            <a:avLst/>
+          </a:prstGeom>
+          <a:noFill/>
+          <a:ln/>
+        </p:spPr>
+        <p:txBody>
+          <a:bodyPr wrap="square" lIns="0" tIns="0" rIns="0" bIns="0" rtlCol="0" anchor="ctr"/>
+          <a:lstStyle/>
+          <a:p>
+            <a:pPr algn="ctr" indent="0" marL="0">
+              <a:buNone/>
+            </a:pPr>
+            <a:r>
+              <a:rPr lang="en-US" sz="1500" b="1" dirty="0">
+                <a:solidFill>
+                  <a:srgbClr val="11161C"/>
+                </a:solidFill>
+                <a:latin typeface="Arial" pitchFamily="34" charset="0"/>
+                <a:ea typeface="Arial" pitchFamily="34" charset="-122"/>
+                <a:cs typeface="Arial" pitchFamily="34" charset="-120"/>
+              </a:rPr>
+              <a:t>7</a:t>
+            </a:r>
+            <a:endParaRPr lang="en-US" sz="1500" dirty="0"/>
+          </a:p>
+          <a:p>
+            <a:pPr algn="ctr" indent="0" marL="0">
+              <a:buNone/>
+            </a:pPr>
+            <a:r>
+              <a:rPr lang="en-US" sz="1700" dirty="0">
+                <a:solidFill>
+                  <a:srgbClr val="11161C"/>
+                </a:solidFill>
+                <a:latin typeface="Arial" pitchFamily="34" charset="0"/>
+                <a:ea typeface="Arial" pitchFamily="34" charset="-122"/>
+                <a:cs typeface="Arial" pitchFamily="34" charset="-120"/>
+              </a:rPr>
+              <a:t>♠</a:t>
+            </a:r>
+            <a:endParaRPr lang="en-US" sz="1500" dirty="0"/>
+          </a:p>
+        </p:txBody>
+      </p:sp>
+      <p:sp>
+        <p:nvSpPr>
+          <p:cNvPr id="16" name="card 10H"/>
+          <p:cNvSpPr/>
+          <p:nvPr/>
+        </p:nvSpPr>
+        <p:spPr>
+          <a:xfrm>
+            <a:off x="4023360" y="2377440"/>
+            <a:ext cx="566928" cy="786384"/>
+          </a:xfrm>
+          <a:prstGeom prst="roundRect">
+            <a:avLst>
+              <a:gd name="adj" fmla="val 9677"/>
+            </a:avLst>
+          </a:prstGeom>
+          <a:solidFill>
+            <a:srgbClr val="F4F6F8"/>
+          </a:solidFill>
+          <a:ln w="9525">
+            <a:solidFill>
+              <a:srgbClr val="C9D1D9"/>
+            </a:solidFill>
+            <a:prstDash val="solid"/>
+          </a:ln>
+        </p:spPr>
+      </p:sp>
+      <p:sp>
+        <p:nvSpPr>
+          <p:cNvPr id="17" name="Text 15"/>
+          <p:cNvSpPr txBox="1"/>
+          <p:nvPr/>
+        </p:nvSpPr>
+        <p:spPr>
+          <a:xfrm>
+            <a:off x="4023360" y="2414016"/>
+            <a:ext cx="566928" cy="713232"/>
+          </a:xfrm>
+          <a:prstGeom prst="rect">
+            <a:avLst/>
+          </a:prstGeom>
+          <a:noFill/>
+          <a:ln/>
+        </p:spPr>
+        <p:txBody>
+          <a:bodyPr wrap="square" lIns="0" tIns="0" rIns="0" bIns="0" rtlCol="0" anchor="ctr"/>
+          <a:lstStyle/>
+          <a:p>
+            <a:pPr algn="ctr" indent="0" marL="0">
+              <a:buNone/>
+            </a:pPr>
+            <a:r>
+              <a:rPr lang="en-US" sz="1500" b="1" dirty="0">
+                <a:solidFill>
+                  <a:srgbClr val="C8282E"/>
+                </a:solidFill>
+                <a:latin typeface="Arial" pitchFamily="34" charset="0"/>
+                <a:ea typeface="Arial" pitchFamily="34" charset="-122"/>
+                <a:cs typeface="Arial" pitchFamily="34" charset="-120"/>
+              </a:rPr>
+              <a:t>10</a:t>
+            </a:r>
+            <a:endParaRPr lang="en-US" sz="1500" dirty="0"/>
+          </a:p>
+          <a:p>
+            <a:pPr algn="ctr" indent="0" marL="0">
+              <a:buNone/>
+            </a:pPr>
+            <a:r>
+              <a:rPr lang="en-US" sz="1700" dirty="0">
+                <a:solidFill>
+                  <a:srgbClr val="C8282E"/>
+                </a:solidFill>
+                <a:latin typeface="Arial" pitchFamily="34" charset="0"/>
+                <a:ea typeface="Arial" pitchFamily="34" charset="-122"/>
+                <a:cs typeface="Arial" pitchFamily="34" charset="-120"/>
+              </a:rPr>
+              <a:t>♥</a:t>
+            </a:r>
+            <a:endParaRPr lang="en-US" sz="1500" dirty="0"/>
+          </a:p>
+        </p:txBody>
+      </p:sp>
+      <p:sp>
+        <p:nvSpPr>
+          <p:cNvPr id="18" name="card KC"/>
+          <p:cNvSpPr/>
+          <p:nvPr/>
+        </p:nvSpPr>
+        <p:spPr>
+          <a:xfrm>
+            <a:off x="4663440" y="2377440"/>
+            <a:ext cx="566928" cy="786384"/>
+          </a:xfrm>
+          <a:prstGeom prst="roundRect">
+            <a:avLst>
+              <a:gd name="adj" fmla="val 9677"/>
+            </a:avLst>
+          </a:prstGeom>
+          <a:solidFill>
+            <a:srgbClr val="F4F6F8"/>
+          </a:solidFill>
+          <a:ln w="9525">
+            <a:solidFill>
+              <a:srgbClr val="C9D1D9"/>
+            </a:solidFill>
+            <a:prstDash val="solid"/>
+          </a:ln>
+        </p:spPr>
+      </p:sp>
+      <p:sp>
+        <p:nvSpPr>
+          <p:cNvPr id="19" name="Text 17"/>
+          <p:cNvSpPr txBox="1"/>
+          <p:nvPr/>
+        </p:nvSpPr>
+        <p:spPr>
+          <a:xfrm>
+            <a:off x="4663440" y="2414016"/>
+            <a:ext cx="566928" cy="713232"/>
+          </a:xfrm>
+          <a:prstGeom prst="rect">
+            <a:avLst/>
+          </a:prstGeom>
+          <a:noFill/>
+          <a:ln/>
+        </p:spPr>
+        <p:txBody>
+          <a:bodyPr wrap="square" lIns="0" tIns="0" rIns="0" bIns="0" rtlCol="0" anchor="ctr"/>
+          <a:lstStyle/>
+          <a:p>
+            <a:pPr algn="ctr" indent="0" marL="0">
+              <a:buNone/>
+            </a:pPr>
+            <a:r>
+              <a:rPr lang="en-US" sz="1500" b="1" dirty="0">
+                <a:solidFill>
+                  <a:srgbClr val="11161C"/>
+                </a:solidFill>
+                <a:latin typeface="Arial" pitchFamily="34" charset="0"/>
+                <a:ea typeface="Arial" pitchFamily="34" charset="-122"/>
+                <a:cs typeface="Arial" pitchFamily="34" charset="-120"/>
+              </a:rPr>
+              <a:t>K</a:t>
+            </a:r>
+            <a:endParaRPr lang="en-US" sz="1500" dirty="0"/>
+          </a:p>
+          <a:p>
+            <a:pPr algn="ctr" indent="0" marL="0">
+              <a:buNone/>
+            </a:pPr>
+            <a:r>
+              <a:rPr lang="en-US" sz="1700" dirty="0">
+                <a:solidFill>
+                  <a:srgbClr val="11161C"/>
+                </a:solidFill>
+                <a:latin typeface="Arial" pitchFamily="34" charset="0"/>
+                <a:ea typeface="Arial" pitchFamily="34" charset="-122"/>
+                <a:cs typeface="Arial" pitchFamily="34" charset="-120"/>
+              </a:rPr>
+              <a:t>♣</a:t>
+            </a:r>
+            <a:endParaRPr lang="en-US" sz="1500" dirty="0"/>
+          </a:p>
+        </p:txBody>
+      </p:sp>
+      <p:sp>
+        <p:nvSpPr>
+          <p:cNvPr id="20" name="card 10C"/>
+          <p:cNvSpPr/>
+          <p:nvPr/>
+        </p:nvSpPr>
+        <p:spPr>
+          <a:xfrm>
+            <a:off x="5303520" y="2377440"/>
+            <a:ext cx="566928" cy="786384"/>
+          </a:xfrm>
+          <a:prstGeom prst="roundRect">
+            <a:avLst>
+              <a:gd name="adj" fmla="val 9677"/>
+            </a:avLst>
+          </a:prstGeom>
+          <a:solidFill>
+            <a:srgbClr val="F4F6F8"/>
+          </a:solidFill>
+          <a:ln w="9525">
+            <a:solidFill>
+              <a:srgbClr val="C9D1D9"/>
+            </a:solidFill>
+            <a:prstDash val="solid"/>
+          </a:ln>
+        </p:spPr>
+      </p:sp>
+      <p:sp>
+        <p:nvSpPr>
+          <p:cNvPr id="21" name="Text 19"/>
+          <p:cNvSpPr txBox="1"/>
+          <p:nvPr/>
+        </p:nvSpPr>
+        <p:spPr>
+          <a:xfrm>
+            <a:off x="5303520" y="2414016"/>
+            <a:ext cx="566928" cy="713232"/>
+          </a:xfrm>
+          <a:prstGeom prst="rect">
+            <a:avLst/>
+          </a:prstGeom>
+          <a:noFill/>
+          <a:ln/>
+        </p:spPr>
+        <p:txBody>
+          <a:bodyPr wrap="square" lIns="0" tIns="0" rIns="0" bIns="0" rtlCol="0" anchor="ctr"/>
+          <a:lstStyle/>
+          <a:p>
+            <a:pPr algn="ctr" indent="0" marL="0">
+              <a:buNone/>
+            </a:pPr>
+            <a:r>
+              <a:rPr lang="en-US" sz="1500" b="1" dirty="0">
+                <a:solidFill>
+                  <a:srgbClr val="11161C"/>
+                </a:solidFill>
+                <a:latin typeface="Arial" pitchFamily="34" charset="0"/>
+                <a:ea typeface="Arial" pitchFamily="34" charset="-122"/>
+                <a:cs typeface="Arial" pitchFamily="34" charset="-120"/>
+              </a:rPr>
+              <a:t>10</a:t>
+            </a:r>
+            <a:endParaRPr lang="en-US" sz="1500" dirty="0"/>
+          </a:p>
+          <a:p>
+            <a:pPr algn="ctr" indent="0" marL="0">
+              <a:buNone/>
+            </a:pPr>
+            <a:r>
+              <a:rPr lang="en-US" sz="1700" dirty="0">
+                <a:solidFill>
+                  <a:srgbClr val="11161C"/>
+                </a:solidFill>
+                <a:latin typeface="Arial" pitchFamily="34" charset="0"/>
+                <a:ea typeface="Arial" pitchFamily="34" charset="-122"/>
+                <a:cs typeface="Arial" pitchFamily="34" charset="-120"/>
+              </a:rPr>
+              <a:t>♣</a:t>
+            </a:r>
+            <a:endParaRPr lang="en-US" sz="1500" dirty="0"/>
+          </a:p>
+        </p:txBody>
+      </p:sp>
+      <p:sp>
+        <p:nvSpPr>
+          <p:cNvPr id="22" name="Text 20"/>
+          <p:cNvSpPr txBox="1"/>
+          <p:nvPr/>
+        </p:nvSpPr>
+        <p:spPr>
+          <a:xfrm>
+            <a:off x="822960" y="3246120"/>
+            <a:ext cx="6400800" cy="320040"/>
+          </a:xfrm>
+          <a:prstGeom prst="rect">
+            <a:avLst/>
+          </a:prstGeom>
+          <a:noFill/>
+          <a:ln/>
+        </p:spPr>
+        <p:txBody>
+          <a:bodyPr wrap="square" lIns="0" tIns="0" rIns="0" bIns="0" rtlCol="0" anchor="t"/>
+          <a:lstStyle/>
+          <a:p>
+            <a:pPr indent="0" marL="0">
+              <a:buNone/>
+            </a:pPr>
+            <a:r>
+              <a:rPr lang="en-US" sz="1300" dirty="0">
+                <a:solidFill>
+                  <a:schemeClr val="tx2"/>
+                </a:solidFill>
+              </a:rPr>
+              <a:t>Big trumps — but not the Jack or the Nine, the opponent holds both.</a:t>
+            </a:r>
+            <a:endParaRPr lang="en-US" sz="1300" dirty="0"/>
+          </a:p>
+        </p:txBody>
+      </p:sp>
+      <p:sp>
+        <p:nvSpPr>
+          <p:cNvPr id="23" name="deal play 0"/>
+          <p:cNvSpPr/>
+          <p:nvPr/>
+        </p:nvSpPr>
+        <p:spPr>
+          <a:xfrm>
+            <a:off x="822960" y="3749040"/>
+            <a:ext cx="6400800" cy="914400"/>
+          </a:xfrm>
+          <a:prstGeom prst="roundRect">
+            <a:avLst>
+              <a:gd name="adj" fmla="val 6000"/>
+            </a:avLst>
+          </a:prstGeom>
+          <a:solidFill>
+            <a:schemeClr val="bg1"/>
+          </a:solidFill>
+          <a:ln w="12700">
+            <a:solidFill>
+              <a:schemeClr val="accent6"/>
+            </a:solidFill>
+            <a:prstDash val="solid"/>
+          </a:ln>
+        </p:spPr>
+      </p:sp>
+      <p:sp>
+        <p:nvSpPr>
+          <p:cNvPr id="24" name="Text 22"/>
+          <p:cNvSpPr txBox="1"/>
+          <p:nvPr/>
+        </p:nvSpPr>
+        <p:spPr>
+          <a:xfrm>
+            <a:off x="1005840" y="3840480"/>
+            <a:ext cx="1463040" cy="731520"/>
+          </a:xfrm>
+          <a:prstGeom prst="rect">
+            <a:avLst/>
+          </a:prstGeom>
+          <a:noFill/>
+          <a:ln/>
+        </p:spPr>
+        <p:txBody>
+          <a:bodyPr wrap="square" lIns="0" tIns="0" rIns="0" bIns="0" rtlCol="0" anchor="ctr"/>
+          <a:lstStyle/>
+          <a:p>
+            <a:pPr indent="0" marL="0">
+              <a:buNone/>
+            </a:pPr>
+            <a:r>
+              <a:rPr lang="en-US" sz="1400" b="1" dirty="0">
+                <a:solidFill>
+                  <a:schemeClr val="tx1"/>
+                </a:solidFill>
+              </a:rPr>
+              <a:t>TrumpCount</a:t>
+            </a:r>
+            <a:endParaRPr lang="en-US" sz="1400" dirty="0"/>
+          </a:p>
+        </p:txBody>
+      </p:sp>
+      <p:sp>
+        <p:nvSpPr>
+          <p:cNvPr id="25" name="Text 23"/>
+          <p:cNvSpPr txBox="1"/>
+          <p:nvPr/>
+        </p:nvSpPr>
+        <p:spPr>
+          <a:xfrm>
+            <a:off x="2468880" y="3840480"/>
+            <a:ext cx="3566160" cy="731520"/>
+          </a:xfrm>
+          <a:prstGeom prst="rect">
+            <a:avLst/>
+          </a:prstGeom>
+          <a:noFill/>
+          <a:ln/>
+        </p:spPr>
+        <p:txBody>
+          <a:bodyPr wrap="square" lIns="0" tIns="0" rIns="0" bIns="0" rtlCol="0" anchor="ctr"/>
+          <a:lstStyle/>
+          <a:p>
+            <a:pPr indent="0" marL="0">
+              <a:buNone/>
+            </a:pPr>
+            <a:r>
+              <a:rPr lang="en-US" sz="1200" dirty="0">
+                <a:solidFill>
+                  <a:schemeClr val="tx2"/>
+                </a:solidFill>
+              </a:rPr>
+              <a:t>Leads the Ace of trump at once → captured by the Jack (−31 pts).</a:t>
+            </a:r>
+            <a:endParaRPr lang="en-US" sz="1200" dirty="0"/>
+          </a:p>
+        </p:txBody>
+      </p:sp>
+      <p:sp>
+        <p:nvSpPr>
+          <p:cNvPr id="26" name="Text 24"/>
+          <p:cNvSpPr txBox="1"/>
+          <p:nvPr/>
+        </p:nvSpPr>
+        <p:spPr>
+          <a:xfrm>
+            <a:off x="6035040" y="3840480"/>
+            <a:ext cx="1097280" cy="731520"/>
+          </a:xfrm>
+          <a:prstGeom prst="rect">
+            <a:avLst/>
+          </a:prstGeom>
+          <a:noFill/>
+          <a:ln/>
+        </p:spPr>
+        <p:txBody>
+          <a:bodyPr wrap="square" lIns="0" tIns="0" rIns="0" bIns="0" rtlCol="0" anchor="ctr"/>
+          <a:lstStyle/>
+          <a:p>
+            <a:pPr algn="r" indent="0" marL="0">
+              <a:buNone/>
+            </a:pPr>
+            <a:r>
+              <a:rPr lang="en-US" sz="2400" b="1" dirty="0">
+                <a:solidFill>
+                  <a:schemeClr val="tx2"/>
+                </a:solidFill>
+                <a:latin typeface="Courier New" pitchFamily="34" charset="0"/>
+                <a:ea typeface="Courier New" pitchFamily="34" charset="-122"/>
+                <a:cs typeface="Courier New" pitchFamily="34" charset="-120"/>
+              </a:rPr>
+              <a:t>7</a:t>
+            </a:r>
+            <a:pPr algn="r" indent="0" marL="0">
+              <a:buNone/>
+            </a:pPr>
+            <a:r>
+              <a:rPr lang="en-US" sz="1100" dirty="0">
+                <a:solidFill>
+                  <a:schemeClr val="tx2"/>
+                </a:solidFill>
+                <a:latin typeface="Courier New" pitchFamily="34" charset="0"/>
+                <a:ea typeface="Courier New" pitchFamily="34" charset="-122"/>
+                <a:cs typeface="Courier New" pitchFamily="34" charset="-120"/>
+              </a:rPr>
+              <a:t> pts</a:t>
+            </a:r>
+            <a:endParaRPr lang="en-US" sz="2400" dirty="0"/>
+          </a:p>
+        </p:txBody>
+      </p:sp>
+      <p:sp>
+        <p:nvSpPr>
+          <p:cNvPr id="27" name="deal play 1"/>
+          <p:cNvSpPr/>
+          <p:nvPr/>
+        </p:nvSpPr>
+        <p:spPr>
+          <a:xfrm>
+            <a:off x="822960" y="4846320"/>
+            <a:ext cx="6400800" cy="914400"/>
+          </a:xfrm>
+          <a:prstGeom prst="roundRect">
+            <a:avLst>
+              <a:gd name="adj" fmla="val 6000"/>
+            </a:avLst>
+          </a:prstGeom>
+          <a:solidFill>
+            <a:schemeClr val="bg1"/>
+          </a:solidFill>
+          <a:ln w="12700">
+            <a:solidFill>
+              <a:schemeClr val="accent1"/>
+            </a:solidFill>
+            <a:prstDash val="solid"/>
+          </a:ln>
+        </p:spPr>
+      </p:sp>
+      <p:sp>
+        <p:nvSpPr>
+          <p:cNvPr id="28" name="Text 26"/>
+          <p:cNvSpPr txBox="1"/>
+          <p:nvPr/>
+        </p:nvSpPr>
+        <p:spPr>
+          <a:xfrm>
+            <a:off x="1005840" y="4937760"/>
+            <a:ext cx="1463040" cy="731520"/>
+          </a:xfrm>
+          <a:prstGeom prst="rect">
+            <a:avLst/>
+          </a:prstGeom>
+          <a:noFill/>
+          <a:ln/>
+        </p:spPr>
+        <p:txBody>
+          <a:bodyPr wrap="square" lIns="0" tIns="0" rIns="0" bIns="0" rtlCol="0" anchor="ctr"/>
+          <a:lstStyle/>
+          <a:p>
+            <a:pPr indent="0" marL="0">
+              <a:buNone/>
+            </a:pPr>
+            <a:r>
+              <a:rPr lang="en-US" sz="1400" b="1" dirty="0">
+                <a:solidFill>
+                  <a:schemeClr val="tx1"/>
+                </a:solidFill>
+              </a:rPr>
+              <a:t>PPO agent</a:t>
+            </a:r>
+            <a:endParaRPr lang="en-US" sz="1400" dirty="0"/>
+          </a:p>
+        </p:txBody>
+      </p:sp>
+      <p:sp>
+        <p:nvSpPr>
+          <p:cNvPr id="29" name="Text 27"/>
+          <p:cNvSpPr txBox="1"/>
+          <p:nvPr/>
+        </p:nvSpPr>
+        <p:spPr>
+          <a:xfrm>
+            <a:off x="2468880" y="4937760"/>
+            <a:ext cx="3566160" cy="731520"/>
+          </a:xfrm>
+          <a:prstGeom prst="rect">
+            <a:avLst/>
+          </a:prstGeom>
+          <a:noFill/>
+          <a:ln/>
+        </p:spPr>
+        <p:txBody>
+          <a:bodyPr wrap="square" lIns="0" tIns="0" rIns="0" bIns="0" rtlCol="0" anchor="ctr"/>
+          <a:lstStyle/>
+          <a:p>
+            <a:pPr indent="0" marL="0">
+              <a:buNone/>
+            </a:pPr>
+            <a:r>
+              <a:rPr lang="en-US" sz="1200" dirty="0">
+                <a:solidFill>
+                  <a:schemeClr val="tx2"/>
+                </a:solidFill>
+              </a:rPr>
+              <a:t>Ducks under the Jack with the 8, flushes out the Nine with the Queen, then cashes 10 + Ace as masters.</a:t>
+            </a:r>
+            <a:endParaRPr lang="en-US" sz="1200" dirty="0"/>
+          </a:p>
+        </p:txBody>
+      </p:sp>
+      <p:sp>
+        <p:nvSpPr>
+          <p:cNvPr id="30" name="Text 28"/>
+          <p:cNvSpPr txBox="1"/>
+          <p:nvPr/>
+        </p:nvSpPr>
+        <p:spPr>
+          <a:xfrm>
+            <a:off x="6035040" y="4937760"/>
+            <a:ext cx="1097280" cy="731520"/>
+          </a:xfrm>
+          <a:prstGeom prst="rect">
+            <a:avLst/>
+          </a:prstGeom>
+          <a:noFill/>
+          <a:ln/>
+        </p:spPr>
+        <p:txBody>
+          <a:bodyPr wrap="square" lIns="0" tIns="0" rIns="0" bIns="0" rtlCol="0" anchor="ctr"/>
+          <a:lstStyle/>
+          <a:p>
+            <a:pPr algn="r" indent="0" marL="0">
+              <a:buNone/>
+            </a:pPr>
+            <a:r>
+              <a:rPr lang="en-US" sz="2400" b="1" dirty="0">
+                <a:solidFill>
+                  <a:schemeClr val="accent1"/>
+                </a:solidFill>
+                <a:latin typeface="Courier New" pitchFamily="34" charset="0"/>
+                <a:ea typeface="Courier New" pitchFamily="34" charset="-122"/>
+                <a:cs typeface="Courier New" pitchFamily="34" charset="-120"/>
+              </a:rPr>
+              <a:t>58</a:t>
+            </a:r>
+            <a:pPr algn="r" indent="0" marL="0">
+              <a:buNone/>
+            </a:pPr>
+            <a:r>
+              <a:rPr lang="en-US" sz="1100" dirty="0">
+                <a:solidFill>
+                  <a:schemeClr val="tx2"/>
+                </a:solidFill>
+                <a:latin typeface="Courier New" pitchFamily="34" charset="0"/>
+                <a:ea typeface="Courier New" pitchFamily="34" charset="-122"/>
+                <a:cs typeface="Courier New" pitchFamily="34" charset="-120"/>
+              </a:rPr>
+              <a:t> pts</a:t>
+            </a:r>
+            <a:endParaRPr lang="en-US" sz="2400" dirty="0"/>
+          </a:p>
+        </p:txBody>
+      </p:sp>
+      <p:sp>
+        <p:nvSpPr>
+          <p:cNvPr id="31" name="learned card"/>
+          <p:cNvSpPr/>
+          <p:nvPr/>
+        </p:nvSpPr>
+        <p:spPr>
+          <a:xfrm>
+            <a:off x="7772400" y="1783080"/>
+            <a:ext cx="3840480" cy="2057400"/>
+          </a:xfrm>
+          <a:prstGeom prst="roundRect">
+            <a:avLst>
+              <a:gd name="adj" fmla="val 3556"/>
             </a:avLst>
           </a:prstGeom>
           <a:solidFill>
@@ -10186,13 +10427,13 @@
       </p:sp>
       <p:sp>
         <p:nvSpPr>
-          <p:cNvPr id="8" name="Text 6"/>
-          <p:cNvSpPr txBox="1"/>
-          <p:nvPr/>
-        </p:nvSpPr>
-        <p:spPr>
-          <a:xfrm>
-            <a:off x="6492240" y="2011680"/>
+          <p:cNvPr id="32" name="Text 30"/>
+          <p:cNvSpPr txBox="1"/>
+          <p:nvPr/>
+        </p:nvSpPr>
+        <p:spPr>
+          <a:xfrm>
+            <a:off x="8046720" y="2011680"/>
             <a:ext cx="6400800" cy="274320"/>
           </a:xfrm>
           <a:prstGeom prst="rect">
@@ -10217,7 +10458,7 @@
                 <a:ea typeface="Courier New" pitchFamily="34" charset="-122"/>
                 <a:cs typeface="Courier New" pitchFamily="34" charset="-120"/>
               </a:rPr>
-              <a:t>NEXT</a:t>
+              <a:t>LEARNED ALONE</a:t>
             </a:r>
             <a:endParaRPr lang="en-US" sz="1100" dirty="0"/>
           </a:p>
@@ -10225,14 +10466,117 @@
       </p:sp>
       <p:sp>
         <p:nvSpPr>
-          <p:cNvPr id="9" name="Text 7"/>
-          <p:cNvSpPr txBox="1"/>
-          <p:nvPr/>
-        </p:nvSpPr>
-        <p:spPr>
-          <a:xfrm>
-            <a:off x="6492240" y="2423160"/>
-            <a:ext cx="548640" cy="365760"/>
+          <p:cNvPr id="33" name="Text 31"/>
+          <p:cNvSpPr txBox="1"/>
+          <p:nvPr/>
+        </p:nvSpPr>
+        <p:spPr>
+          <a:xfrm>
+            <a:off x="8046720" y="2377440"/>
+            <a:ext cx="3383280" cy="1371600"/>
+          </a:xfrm>
+          <a:prstGeom prst="rect">
+            <a:avLst/>
+          </a:prstGeom>
+          <a:noFill/>
+          <a:ln/>
+        </p:spPr>
+        <p:txBody>
+          <a:bodyPr wrap="square" lIns="0" tIns="0" rIns="0" bIns="0" rtlCol="0" anchor="t"/>
+          <a:lstStyle/>
+          <a:p>
+            <a:pPr marL="203200" indent="-203200">
+              <a:spcAft>
+                <a:spcPts val="800"/>
+              </a:spcAft>
+              <a:buSzPct val="100000"/>
+              <a:buChar char="•"/>
+            </a:pPr>
+            <a:r>
+              <a:rPr lang="en-US" sz="1300" dirty="0">
+                <a:solidFill>
+                  <a:schemeClr val="tx1"/>
+                </a:solidFill>
+              </a:rPr>
+              <a:t>Wait for the opponent's top trumps to fall</a:t>
+            </a:r>
+            <a:endParaRPr lang="en-US" sz="1500" dirty="0"/>
+          </a:p>
+          <a:p>
+            <a:pPr marL="203200" indent="-203200">
+              <a:spcAft>
+                <a:spcPts val="800"/>
+              </a:spcAft>
+              <a:buSzPct val="100000"/>
+              <a:buChar char="•"/>
+            </a:pPr>
+            <a:r>
+              <a:rPr lang="en-US" sz="1300" dirty="0">
+                <a:solidFill>
+                  <a:schemeClr val="tx1"/>
+                </a:solidFill>
+              </a:rPr>
+              <a:t>Profitable ruffs</a:t>
+            </a:r>
+            <a:endParaRPr lang="en-US" sz="1500" dirty="0"/>
+          </a:p>
+          <a:p>
+            <a:pPr marL="203200" indent="-203200">
+              <a:spcAft>
+                <a:spcPts val="800"/>
+              </a:spcAft>
+              <a:buSzPct val="100000"/>
+              <a:buChar char="•"/>
+            </a:pPr>
+            <a:r>
+              <a:rPr lang="en-US" sz="1300" dirty="0">
+                <a:solidFill>
+                  <a:schemeClr val="tx1"/>
+                </a:solidFill>
+              </a:rPr>
+              <a:t>Cash master cards at the end</a:t>
+            </a:r>
+            <a:endParaRPr lang="en-US" sz="1500" dirty="0"/>
+          </a:p>
+        </p:txBody>
+      </p:sp>
+      <p:sp>
+        <p:nvSpPr>
+          <p:cNvPr id="34" name="mistake card"/>
+          <p:cNvSpPr/>
+          <p:nvPr/>
+        </p:nvSpPr>
+        <p:spPr>
+          <a:xfrm>
+            <a:off x="7772400" y="4069080"/>
+            <a:ext cx="3840480" cy="2057400"/>
+          </a:xfrm>
+          <a:prstGeom prst="roundRect">
+            <a:avLst>
+              <a:gd name="adj" fmla="val 3556"/>
+            </a:avLst>
+          </a:prstGeom>
+          <a:solidFill>
+            <a:schemeClr val="bg2"/>
+          </a:solidFill>
+          <a:ln w="9525">
+            <a:solidFill>
+              <a:schemeClr val="accent6"/>
+            </a:solidFill>
+            <a:prstDash val="solid"/>
+          </a:ln>
+        </p:spPr>
+      </p:sp>
+      <p:sp>
+        <p:nvSpPr>
+          <p:cNvPr id="35" name="Text 33"/>
+          <p:cNvSpPr txBox="1"/>
+          <p:nvPr/>
+        </p:nvSpPr>
+        <p:spPr>
+          <a:xfrm>
+            <a:off x="8046720" y="4297680"/>
+            <a:ext cx="6400800" cy="274320"/>
           </a:xfrm>
           <a:prstGeom prst="rect">
             <a:avLst/>
@@ -10248,30 +10592,30 @@
               <a:buNone/>
             </a:pPr>
             <a:r>
-              <a:rPr lang="en-US" sz="1500" b="1" dirty="0">
-                <a:solidFill>
-                  <a:schemeClr val="accent1"/>
+              <a:rPr lang="en-US" sz="1100" b="1" dirty="0">
+                <a:solidFill>
+                  <a:schemeClr val="accent2"/>
                 </a:solidFill>
                 <a:latin typeface="Courier New" pitchFamily="34" charset="0"/>
                 <a:ea typeface="Courier New" pitchFamily="34" charset="-122"/>
                 <a:cs typeface="Courier New" pitchFamily="34" charset="-120"/>
               </a:rPr>
-              <a:t>01</a:t>
-            </a:r>
-            <a:endParaRPr lang="en-US" sz="1500" dirty="0"/>
-          </a:p>
-        </p:txBody>
-      </p:sp>
-      <p:sp>
-        <p:nvSpPr>
-          <p:cNvPr id="10" name="Text 8"/>
-          <p:cNvSpPr txBox="1"/>
-          <p:nvPr/>
-        </p:nvSpPr>
-        <p:spPr>
-          <a:xfrm>
-            <a:off x="7086600" y="2423160"/>
-            <a:ext cx="4297680" cy="347472"/>
+              <a:t>STILL WRONG</a:t>
+            </a:r>
+            <a:endParaRPr lang="en-US" sz="1100" dirty="0"/>
+          </a:p>
+        </p:txBody>
+      </p:sp>
+      <p:sp>
+        <p:nvSpPr>
+          <p:cNvPr id="36" name="Text 34"/>
+          <p:cNvSpPr txBox="1"/>
+          <p:nvPr/>
+        </p:nvSpPr>
+        <p:spPr>
+          <a:xfrm>
+            <a:off x="8046720" y="4663440"/>
+            <a:ext cx="3383280" cy="1371600"/>
           </a:xfrm>
           <a:prstGeom prst="rect">
             <a:avLst/>
@@ -10287,381 +10631,26 @@
               <a:buNone/>
             </a:pPr>
             <a:r>
-              <a:rPr lang="en-US" sz="1500" b="1" dirty="0">
+              <a:rPr lang="en-US" sz="1300" dirty="0">
                 <a:solidFill>
                   <a:schemeClr val="tx1"/>
                 </a:solidFill>
               </a:rPr>
-              <a:t>Reproducibility</a:t>
-            </a:r>
-            <a:endParaRPr lang="en-US" sz="1500" dirty="0"/>
-          </a:p>
-        </p:txBody>
-      </p:sp>
-      <p:sp>
-        <p:nvSpPr>
-          <p:cNvPr id="11" name="Text 9"/>
-          <p:cNvSpPr txBox="1"/>
-          <p:nvPr/>
-        </p:nvSpPr>
-        <p:spPr>
-          <a:xfrm>
-            <a:off x="7086600" y="2770632"/>
-            <a:ext cx="4297680" cy="365760"/>
-          </a:xfrm>
-          <a:prstGeom prst="rect">
-            <a:avLst/>
-          </a:prstGeom>
-          <a:noFill/>
-          <a:ln/>
-        </p:spPr>
-        <p:txBody>
-          <a:bodyPr wrap="square" lIns="0" tIns="0" rIns="0" bIns="0" rtlCol="0" anchor="t"/>
-          <a:lstStyle/>
+              <a:t>Leads a Ten while the Ace is still out (−21 pts), with 100% confidence.</a:t>
+            </a:r>
+            <a:endParaRPr lang="en-US" sz="1300" dirty="0"/>
+          </a:p>
           <a:p>
             <a:pPr indent="0" marL="0">
               <a:buNone/>
             </a:pPr>
             <a:r>
-              <a:rPr lang="en-US" sz="1300" dirty="0">
-                <a:solidFill>
-                  <a:schemeClr val="tx2"/>
-                </a:solidFill>
-              </a:rPr>
-              <a:t>Re-run the best setup with 2 more seeds</a:t>
-            </a:r>
-            <a:endParaRPr lang="en-US" sz="1300" dirty="0"/>
-          </a:p>
-        </p:txBody>
-      </p:sp>
-      <p:sp>
-        <p:nvSpPr>
-          <p:cNvPr id="12" name="Text 10"/>
-          <p:cNvSpPr txBox="1"/>
-          <p:nvPr/>
-        </p:nvSpPr>
-        <p:spPr>
-          <a:xfrm>
-            <a:off x="6492240" y="3291840"/>
-            <a:ext cx="548640" cy="365760"/>
-          </a:xfrm>
-          <a:prstGeom prst="rect">
-            <a:avLst/>
-          </a:prstGeom>
-          <a:noFill/>
-          <a:ln/>
-        </p:spPr>
-        <p:txBody>
-          <a:bodyPr wrap="square" lIns="0" tIns="0" rIns="0" bIns="0" rtlCol="0" anchor="ctr"/>
-          <a:lstStyle/>
-          <a:p>
-            <a:pPr indent="0" marL="0">
-              <a:buNone/>
-            </a:pPr>
-            <a:r>
-              <a:rPr lang="en-US" sz="1500" b="1" dirty="0">
+              <a:rPr lang="en-US" sz="1300" b="1" dirty="0">
                 <a:solidFill>
                   <a:schemeClr val="accent1"/>
                 </a:solidFill>
-                <a:latin typeface="Courier New" pitchFamily="34" charset="0"/>
-                <a:ea typeface="Courier New" pitchFamily="34" charset="-122"/>
-                <a:cs typeface="Courier New" pitchFamily="34" charset="-120"/>
-              </a:rPr>
-              <a:t>02</a:t>
-            </a:r>
-            <a:endParaRPr lang="en-US" sz="1500" dirty="0"/>
-          </a:p>
-        </p:txBody>
-      </p:sp>
-      <p:sp>
-        <p:nvSpPr>
-          <p:cNvPr id="13" name="Text 11"/>
-          <p:cNvSpPr txBox="1"/>
-          <p:nvPr/>
-        </p:nvSpPr>
-        <p:spPr>
-          <a:xfrm>
-            <a:off x="7086600" y="3291840"/>
-            <a:ext cx="4297680" cy="347472"/>
-          </a:xfrm>
-          <a:prstGeom prst="rect">
-            <a:avLst/>
-          </a:prstGeom>
-          <a:noFill/>
-          <a:ln/>
-        </p:spPr>
-        <p:txBody>
-          <a:bodyPr wrap="square" lIns="0" tIns="0" rIns="0" bIns="0" rtlCol="0" anchor="t"/>
-          <a:lstStyle/>
-          <a:p>
-            <a:pPr indent="0" marL="0">
-              <a:buNone/>
-            </a:pPr>
-            <a:r>
-              <a:rPr lang="en-US" sz="1500" b="1" dirty="0">
-                <a:solidFill>
-                  <a:schemeClr val="tx1"/>
-                </a:solidFill>
-              </a:rPr>
-              <a:t>Memory</a:t>
-            </a:r>
-            <a:endParaRPr lang="en-US" sz="1500" dirty="0"/>
-          </a:p>
-        </p:txBody>
-      </p:sp>
-      <p:sp>
-        <p:nvSpPr>
-          <p:cNvPr id="14" name="Text 12"/>
-          <p:cNvSpPr txBox="1"/>
-          <p:nvPr/>
-        </p:nvSpPr>
-        <p:spPr>
-          <a:xfrm>
-            <a:off x="7086600" y="3639312"/>
-            <a:ext cx="4297680" cy="365760"/>
-          </a:xfrm>
-          <a:prstGeom prst="rect">
-            <a:avLst/>
-          </a:prstGeom>
-          <a:noFill/>
-          <a:ln/>
-        </p:spPr>
-        <p:txBody>
-          <a:bodyPr wrap="square" lIns="0" tIns="0" rIns="0" bIns="0" rtlCol="0" anchor="t"/>
-          <a:lstStyle/>
-          <a:p>
-            <a:pPr indent="0" marL="0">
-              <a:buNone/>
-            </a:pPr>
-            <a:r>
-              <a:rPr lang="en-US" sz="1300" dirty="0">
-                <a:solidFill>
-                  <a:schemeClr val="tx2"/>
-                </a:solidFill>
-              </a:rPr>
-              <a:t>LSTM or a belief table of the opponent's cards</a:t>
-            </a:r>
-            <a:endParaRPr lang="en-US" sz="1300" dirty="0"/>
-          </a:p>
-        </p:txBody>
-      </p:sp>
-      <p:sp>
-        <p:nvSpPr>
-          <p:cNvPr id="15" name="Text 13"/>
-          <p:cNvSpPr txBox="1"/>
-          <p:nvPr/>
-        </p:nvSpPr>
-        <p:spPr>
-          <a:xfrm>
-            <a:off x="6492240" y="4160520"/>
-            <a:ext cx="548640" cy="365760"/>
-          </a:xfrm>
-          <a:prstGeom prst="rect">
-            <a:avLst/>
-          </a:prstGeom>
-          <a:noFill/>
-          <a:ln/>
-        </p:spPr>
-        <p:txBody>
-          <a:bodyPr wrap="square" lIns="0" tIns="0" rIns="0" bIns="0" rtlCol="0" anchor="ctr"/>
-          <a:lstStyle/>
-          <a:p>
-            <a:pPr indent="0" marL="0">
-              <a:buNone/>
-            </a:pPr>
-            <a:r>
-              <a:rPr lang="en-US" sz="1500" b="1" dirty="0">
-                <a:solidFill>
-                  <a:schemeClr val="accent1"/>
-                </a:solidFill>
-                <a:latin typeface="Courier New" pitchFamily="34" charset="0"/>
-                <a:ea typeface="Courier New" pitchFamily="34" charset="-122"/>
-                <a:cs typeface="Courier New" pitchFamily="34" charset="-120"/>
-              </a:rPr>
-              <a:t>03</a:t>
-            </a:r>
-            <a:endParaRPr lang="en-US" sz="1500" dirty="0"/>
-          </a:p>
-        </p:txBody>
-      </p:sp>
-      <p:sp>
-        <p:nvSpPr>
-          <p:cNvPr id="16" name="Text 14"/>
-          <p:cNvSpPr txBox="1"/>
-          <p:nvPr/>
-        </p:nvSpPr>
-        <p:spPr>
-          <a:xfrm>
-            <a:off x="7086600" y="4160520"/>
-            <a:ext cx="4297680" cy="347472"/>
-          </a:xfrm>
-          <a:prstGeom prst="rect">
-            <a:avLst/>
-          </a:prstGeom>
-          <a:noFill/>
-          <a:ln/>
-        </p:spPr>
-        <p:txBody>
-          <a:bodyPr wrap="square" lIns="0" tIns="0" rIns="0" bIns="0" rtlCol="0" anchor="t"/>
-          <a:lstStyle/>
-          <a:p>
-            <a:pPr indent="0" marL="0">
-              <a:buNone/>
-            </a:pPr>
-            <a:r>
-              <a:rPr lang="en-US" sz="1500" b="1" dirty="0">
-                <a:solidFill>
-                  <a:schemeClr val="tx1"/>
-                </a:solidFill>
-              </a:rPr>
-              <a:t>League self-play</a:t>
-            </a:r>
-            <a:endParaRPr lang="en-US" sz="1500" dirty="0"/>
-          </a:p>
-        </p:txBody>
-      </p:sp>
-      <p:sp>
-        <p:nvSpPr>
-          <p:cNvPr id="17" name="Text 15"/>
-          <p:cNvSpPr txBox="1"/>
-          <p:nvPr/>
-        </p:nvSpPr>
-        <p:spPr>
-          <a:xfrm>
-            <a:off x="7086600" y="4507992"/>
-            <a:ext cx="4297680" cy="365760"/>
-          </a:xfrm>
-          <a:prstGeom prst="rect">
-            <a:avLst/>
-          </a:prstGeom>
-          <a:noFill/>
-          <a:ln/>
-        </p:spPr>
-        <p:txBody>
-          <a:bodyPr wrap="square" lIns="0" tIns="0" rIns="0" bIns="0" rtlCol="0" anchor="t"/>
-          <a:lstStyle/>
-          <a:p>
-            <a:pPr indent="0" marL="0">
-              <a:buNone/>
-            </a:pPr>
-            <a:r>
-              <a:rPr lang="en-US" sz="1300" dirty="0">
-                <a:solidFill>
-                  <a:schemeClr val="tx2"/>
-                </a:solidFill>
-              </a:rPr>
-              <a:t>Train against a pool of past versions</a:t>
-            </a:r>
-            <a:endParaRPr lang="en-US" sz="1300" dirty="0"/>
-          </a:p>
-        </p:txBody>
-      </p:sp>
-      <p:sp>
-        <p:nvSpPr>
-          <p:cNvPr id="18" name="Text 16"/>
-          <p:cNvSpPr txBox="1"/>
-          <p:nvPr/>
-        </p:nvSpPr>
-        <p:spPr>
-          <a:xfrm>
-            <a:off x="6492240" y="5029200"/>
-            <a:ext cx="548640" cy="365760"/>
-          </a:xfrm>
-          <a:prstGeom prst="rect">
-            <a:avLst/>
-          </a:prstGeom>
-          <a:noFill/>
-          <a:ln/>
-        </p:spPr>
-        <p:txBody>
-          <a:bodyPr wrap="square" lIns="0" tIns="0" rIns="0" bIns="0" rtlCol="0" anchor="ctr"/>
-          <a:lstStyle/>
-          <a:p>
-            <a:pPr indent="0" marL="0">
-              <a:buNone/>
-            </a:pPr>
-            <a:r>
-              <a:rPr lang="en-US" sz="1500" b="1" dirty="0">
-                <a:solidFill>
-                  <a:schemeClr val="accent1"/>
-                </a:solidFill>
-                <a:latin typeface="Courier New" pitchFamily="34" charset="0"/>
-                <a:ea typeface="Courier New" pitchFamily="34" charset="-122"/>
-                <a:cs typeface="Courier New" pitchFamily="34" charset="-120"/>
-              </a:rPr>
-              <a:t>04</a:t>
-            </a:r>
-            <a:endParaRPr lang="en-US" sz="1500" dirty="0"/>
-          </a:p>
-        </p:txBody>
-      </p:sp>
-      <p:sp>
-        <p:nvSpPr>
-          <p:cNvPr id="19" name="Text 17"/>
-          <p:cNvSpPr txBox="1"/>
-          <p:nvPr/>
-        </p:nvSpPr>
-        <p:spPr>
-          <a:xfrm>
-            <a:off x="7086600" y="5029200"/>
-            <a:ext cx="4297680" cy="347472"/>
-          </a:xfrm>
-          <a:prstGeom prst="rect">
-            <a:avLst/>
-          </a:prstGeom>
-          <a:noFill/>
-          <a:ln/>
-        </p:spPr>
-        <p:txBody>
-          <a:bodyPr wrap="square" lIns="0" tIns="0" rIns="0" bIns="0" rtlCol="0" anchor="t"/>
-          <a:lstStyle/>
-          <a:p>
-            <a:pPr indent="0" marL="0">
-              <a:buNone/>
-            </a:pPr>
-            <a:r>
-              <a:rPr lang="en-US" sz="1500" b="1" dirty="0">
-                <a:solidFill>
-                  <a:schemeClr val="tx1"/>
-                </a:solidFill>
-              </a:rPr>
-              <a:t>Trump choice</a:t>
-            </a:r>
-            <a:endParaRPr lang="en-US" sz="1500" dirty="0"/>
-          </a:p>
-        </p:txBody>
-      </p:sp>
-      <p:sp>
-        <p:nvSpPr>
-          <p:cNvPr id="20" name="Text 18"/>
-          <p:cNvSpPr txBox="1"/>
-          <p:nvPr/>
-        </p:nvSpPr>
-        <p:spPr>
-          <a:xfrm>
-            <a:off x="7086600" y="5376672"/>
-            <a:ext cx="4297680" cy="365760"/>
-          </a:xfrm>
-          <a:prstGeom prst="rect">
-            <a:avLst/>
-          </a:prstGeom>
-          <a:noFill/>
-          <a:ln/>
-        </p:spPr>
-        <p:txBody>
-          <a:bodyPr wrap="square" lIns="0" tIns="0" rIns="0" bIns="0" rtlCol="0" anchor="t"/>
-          <a:lstStyle/>
-          <a:p>
-            <a:pPr indent="0" marL="0">
-              <a:buNone/>
-            </a:pPr>
-            <a:r>
-              <a:rPr lang="en-US" sz="1300" dirty="0">
-                <a:solidFill>
-                  <a:schemeClr val="tx2"/>
-                </a:solidFill>
-              </a:rPr>
-              <a:t>Let the agent bid the trump suit (Phase 4)</a:t>
+              </a:rPr>
+              <a:t>→ weak memory of which high cards remain.</a:t>
             </a:r>
             <a:endParaRPr lang="en-US" sz="1300" dirty="0"/>
           </a:p>
@@ -10726,6 +10715,846 @@
 <file path=ppt/slides/slide17.xml><?xml version="1.0" encoding="utf-8"?>
 <p:sld xmlns:a="http://schemas.openxmlformats.org/drawingml/2006/main" xmlns:r="http://schemas.openxmlformats.org/officeDocument/2006/relationships" xmlns:p="http://schemas.openxmlformats.org/presentationml/2006/main">
   <p:cSld name="Slide 17">
+    <p:spTree>
+      <p:nvGrpSpPr>
+        <p:cNvPr id="1" name=""/>
+        <p:cNvGrpSpPr/>
+        <p:nvPr/>
+      </p:nvGrpSpPr>
+      <p:grpSpPr>
+        <a:xfrm>
+          <a:off x="0" y="0"/>
+          <a:ext cx="0" cy="0"/>
+          <a:chOff x="0" y="0"/>
+          <a:chExt cx="0" cy="0"/>
+        </a:xfrm>
+      </p:grpSpPr>
+      <p:sp>
+        <p:nvSpPr>
+          <p:cNvPr id="2" name="Text 1"/>
+          <p:cNvSpPr/>
+          <p:nvPr>
+            <p:ph idx="101" type="body" hasCustomPrompt="1"/>
+          </p:nvPr>
+        </p:nvSpPr>
+        <p:spPr>
+          <a:xfrm>
+            <a:off x="548640" y="384048"/>
+            <a:ext cx="8229600" cy="292608"/>
+          </a:xfrm>
+          <a:prstGeom prst="rect">
+            <a:avLst/>
+          </a:prstGeom>
+          <a:noFill/>
+          <a:ln/>
+        </p:spPr>
+        <p:txBody>
+          <a:bodyPr wrap="square" lIns="0" tIns="0" rIns="0" bIns="0" rtlCol="0"/>
+          <a:lstStyle/>
+          <a:p>
+            <a:pPr indent="0" marL="0">
+              <a:buNone/>
+            </a:pPr>
+            <a:r>
+              <a:rPr lang="en-US" sz="1200" b="1" spc="200" kern="0" dirty="0">
+                <a:solidFill>
+                  <a:schemeClr val="accent1"/>
+                </a:solidFill>
+                <a:latin typeface="Courier New" pitchFamily="34" charset="0"/>
+                <a:ea typeface="Courier New" pitchFamily="34" charset="-122"/>
+                <a:cs typeface="Courier New" pitchFamily="34" charset="-120"/>
+              </a:rPr>
+              <a:t>16 / NEXT STEPS</a:t>
+            </a:r>
+            <a:endParaRPr lang="en-US" sz="1200" dirty="0"/>
+          </a:p>
+        </p:txBody>
+      </p:sp>
+      <p:sp>
+        <p:nvSpPr>
+          <p:cNvPr id="3" name="Text 1"/>
+          <p:cNvSpPr/>
+          <p:nvPr>
+            <p:ph idx="102" type="title" hasCustomPrompt="1"/>
+          </p:nvPr>
+        </p:nvSpPr>
+        <p:spPr>
+          <a:xfrm>
+            <a:off x="548640" y="713232"/>
+            <a:ext cx="11064240" cy="731520"/>
+          </a:xfrm>
+          <a:prstGeom prst="rect">
+            <a:avLst/>
+          </a:prstGeom>
+          <a:noFill/>
+          <a:ln/>
+        </p:spPr>
+        <p:txBody>
+          <a:bodyPr wrap="square" lIns="0" tIns="0" rIns="0" bIns="0" rtlCol="0" anchor="t"/>
+          <a:lstStyle/>
+          <a:p>
+            <a:pPr algn="l" indent="0" marL="0">
+              <a:buNone/>
+            </a:pPr>
+            <a:r>
+              <a:rPr lang="en-US" sz="3400" b="1" dirty="0">
+                <a:solidFill>
+                  <a:schemeClr val="tx1"/>
+                </a:solidFill>
+              </a:rPr>
+              <a:t>Where we stand — and what comes next</a:t>
+            </a:r>
+            <a:endParaRPr lang="en-US" sz="3400" dirty="0"/>
+          </a:p>
+        </p:txBody>
+      </p:sp>
+      <p:sp>
+        <p:nvSpPr>
+          <p:cNvPr id="4" name="done card"/>
+          <p:cNvSpPr/>
+          <p:nvPr/>
+        </p:nvSpPr>
+        <p:spPr>
+          <a:xfrm>
+            <a:off x="548640" y="1783080"/>
+            <a:ext cx="5394960" cy="4343400"/>
+          </a:xfrm>
+          <a:prstGeom prst="roundRect">
+            <a:avLst>
+              <a:gd name="adj" fmla="val 1684"/>
+            </a:avLst>
+          </a:prstGeom>
+          <a:solidFill>
+            <a:schemeClr val="bg2"/>
+          </a:solidFill>
+          <a:ln w="9525">
+            <a:solidFill>
+              <a:schemeClr val="accent6"/>
+            </a:solidFill>
+            <a:prstDash val="solid"/>
+          </a:ln>
+        </p:spPr>
+      </p:sp>
+      <p:sp>
+        <p:nvSpPr>
+          <p:cNvPr id="5" name="Text 3"/>
+          <p:cNvSpPr txBox="1"/>
+          <p:nvPr/>
+        </p:nvSpPr>
+        <p:spPr>
+          <a:xfrm>
+            <a:off x="822960" y="2011680"/>
+            <a:ext cx="6400800" cy="274320"/>
+          </a:xfrm>
+          <a:prstGeom prst="rect">
+            <a:avLst/>
+          </a:prstGeom>
+          <a:noFill/>
+          <a:ln/>
+        </p:spPr>
+        <p:txBody>
+          <a:bodyPr wrap="square" lIns="0" tIns="0" rIns="0" bIns="0" rtlCol="0" anchor="ctr"/>
+          <a:lstStyle/>
+          <a:p>
+            <a:pPr indent="0" marL="0">
+              <a:buNone/>
+            </a:pPr>
+            <a:r>
+              <a:rPr lang="en-US" sz="1100" b="1" dirty="0">
+                <a:solidFill>
+                  <a:schemeClr val="accent1"/>
+                </a:solidFill>
+                <a:latin typeface="Courier New" pitchFamily="34" charset="0"/>
+                <a:ea typeface="Courier New" pitchFamily="34" charset="-122"/>
+                <a:cs typeface="Courier New" pitchFamily="34" charset="-120"/>
+              </a:rPr>
+              <a:t>DONE</a:t>
+            </a:r>
+            <a:endParaRPr lang="en-US" sz="1100" dirty="0"/>
+          </a:p>
+        </p:txBody>
+      </p:sp>
+      <p:sp>
+        <p:nvSpPr>
+          <p:cNvPr id="6" name="Text 4"/>
+          <p:cNvSpPr txBox="1"/>
+          <p:nvPr/>
+        </p:nvSpPr>
+        <p:spPr>
+          <a:xfrm>
+            <a:off x="822960" y="2423160"/>
+            <a:ext cx="4937760" cy="3566160"/>
+          </a:xfrm>
+          <a:prstGeom prst="rect">
+            <a:avLst/>
+          </a:prstGeom>
+          <a:noFill/>
+          <a:ln/>
+        </p:spPr>
+        <p:txBody>
+          <a:bodyPr wrap="square" lIns="0" tIns="0" rIns="0" bIns="0" rtlCol="0" anchor="t"/>
+          <a:lstStyle/>
+          <a:p>
+            <a:pPr marL="203200" indent="-203200">
+              <a:spcAft>
+                <a:spcPts val="800"/>
+              </a:spcAft>
+              <a:buSzPct val="100000"/>
+              <a:buChar char="•"/>
+            </a:pPr>
+            <a:r>
+              <a:rPr lang="en-US" sz="1400" dirty="0">
+                <a:solidFill>
+                  <a:schemeClr val="tx1"/>
+                </a:solidFill>
+              </a:rPr>
+              <a:t>Tested Belote environment, 4 baselines, PPO from scratch</a:t>
+            </a:r>
+            <a:endParaRPr lang="en-US" sz="1500" dirty="0"/>
+          </a:p>
+          <a:p>
+            <a:pPr marL="203200" indent="-203200">
+              <a:spcAft>
+                <a:spcPts val="800"/>
+              </a:spcAft>
+              <a:buSzPct val="100000"/>
+              <a:buChar char="•"/>
+            </a:pPr>
+            <a:r>
+              <a:rPr lang="en-US" sz="1400" dirty="0">
+                <a:solidFill>
+                  <a:schemeClr val="tx1"/>
+                </a:solidFill>
+              </a:rPr>
+              <a:t>Duplicate-deal evaluation: 2–3× tighter error bars</a:t>
+            </a:r>
+            <a:endParaRPr lang="en-US" sz="1500" dirty="0"/>
+          </a:p>
+          <a:p>
+            <a:pPr marL="203200" indent="-203200">
+              <a:spcAft>
+                <a:spcPts val="800"/>
+              </a:spcAft>
+              <a:buSzPct val="100000"/>
+              <a:buChar char="•"/>
+            </a:pPr>
+            <a:r>
+              <a:rPr lang="en-US" sz="1400" dirty="0">
+                <a:solidFill>
+                  <a:schemeClr val="tx1"/>
+                </a:solidFill>
+              </a:rPr>
+              <a:t>Fixed 2 silent bugs (perspective leak, GAE across seats)</a:t>
+            </a:r>
+            <a:endParaRPr lang="en-US" sz="1500" dirty="0"/>
+          </a:p>
+          <a:p>
+            <a:pPr marL="203200" indent="-203200">
+              <a:spcAft>
+                <a:spcPts val="800"/>
+              </a:spcAft>
+              <a:buSzPct val="100000"/>
+              <a:buChar char="•"/>
+            </a:pPr>
+            <a:r>
+              <a:rPr lang="en-US" sz="1400" dirty="0">
+                <a:solidFill>
+                  <a:schemeClr val="tx1"/>
+                </a:solidFill>
+              </a:rPr>
+              <a:t>Ablations: removing the win bonus is the key change</a:t>
+            </a:r>
+            <a:endParaRPr lang="en-US" sz="1500" dirty="0"/>
+          </a:p>
+          <a:p>
+            <a:pPr marL="203200" indent="-203200">
+              <a:spcAft>
+                <a:spcPts val="800"/>
+              </a:spcAft>
+              <a:buSzPct val="100000"/>
+              <a:buChar char="•"/>
+            </a:pPr>
+            <a:r>
+              <a:rPr lang="en-US" sz="1400" dirty="0">
+                <a:solidFill>
+                  <a:schemeClr val="tx1"/>
+                </a:solidFill>
+              </a:rPr>
+              <a:t>3M games: +5.0 pts / 56% wins vs our best heuristic — reproduced in 3 independent runs</a:t>
+            </a:r>
+            <a:endParaRPr lang="en-US" sz="1500" dirty="0"/>
+          </a:p>
+        </p:txBody>
+      </p:sp>
+      <p:sp>
+        <p:nvSpPr>
+          <p:cNvPr id="7" name="next card"/>
+          <p:cNvSpPr/>
+          <p:nvPr/>
+        </p:nvSpPr>
+        <p:spPr>
+          <a:xfrm>
+            <a:off x="6217920" y="1783080"/>
+            <a:ext cx="5394960" cy="4343400"/>
+          </a:xfrm>
+          <a:prstGeom prst="roundRect">
+            <a:avLst>
+              <a:gd name="adj" fmla="val 1684"/>
+            </a:avLst>
+          </a:prstGeom>
+          <a:solidFill>
+            <a:schemeClr val="bg2"/>
+          </a:solidFill>
+          <a:ln w="9525">
+            <a:solidFill>
+              <a:schemeClr val="accent6"/>
+            </a:solidFill>
+            <a:prstDash val="solid"/>
+          </a:ln>
+        </p:spPr>
+      </p:sp>
+      <p:sp>
+        <p:nvSpPr>
+          <p:cNvPr id="8" name="Text 6"/>
+          <p:cNvSpPr txBox="1"/>
+          <p:nvPr/>
+        </p:nvSpPr>
+        <p:spPr>
+          <a:xfrm>
+            <a:off x="6492240" y="2011680"/>
+            <a:ext cx="6400800" cy="274320"/>
+          </a:xfrm>
+          <a:prstGeom prst="rect">
+            <a:avLst/>
+          </a:prstGeom>
+          <a:noFill/>
+          <a:ln/>
+        </p:spPr>
+        <p:txBody>
+          <a:bodyPr wrap="square" lIns="0" tIns="0" rIns="0" bIns="0" rtlCol="0" anchor="ctr"/>
+          <a:lstStyle/>
+          <a:p>
+            <a:pPr indent="0" marL="0">
+              <a:buNone/>
+            </a:pPr>
+            <a:r>
+              <a:rPr lang="en-US" sz="1100" b="1" dirty="0">
+                <a:solidFill>
+                  <a:schemeClr val="accent1"/>
+                </a:solidFill>
+                <a:latin typeface="Courier New" pitchFamily="34" charset="0"/>
+                <a:ea typeface="Courier New" pitchFamily="34" charset="-122"/>
+                <a:cs typeface="Courier New" pitchFamily="34" charset="-120"/>
+              </a:rPr>
+              <a:t>NEXT</a:t>
+            </a:r>
+            <a:endParaRPr lang="en-US" sz="1100" dirty="0"/>
+          </a:p>
+        </p:txBody>
+      </p:sp>
+      <p:sp>
+        <p:nvSpPr>
+          <p:cNvPr id="9" name="Text 7"/>
+          <p:cNvSpPr txBox="1"/>
+          <p:nvPr/>
+        </p:nvSpPr>
+        <p:spPr>
+          <a:xfrm>
+            <a:off x="6492240" y="2423160"/>
+            <a:ext cx="548640" cy="365760"/>
+          </a:xfrm>
+          <a:prstGeom prst="rect">
+            <a:avLst/>
+          </a:prstGeom>
+          <a:noFill/>
+          <a:ln/>
+        </p:spPr>
+        <p:txBody>
+          <a:bodyPr wrap="square" lIns="0" tIns="0" rIns="0" bIns="0" rtlCol="0" anchor="ctr"/>
+          <a:lstStyle/>
+          <a:p>
+            <a:pPr indent="0" marL="0">
+              <a:buNone/>
+            </a:pPr>
+            <a:r>
+              <a:rPr lang="en-US" sz="1500" b="1" dirty="0">
+                <a:solidFill>
+                  <a:schemeClr val="accent1"/>
+                </a:solidFill>
+                <a:latin typeface="Courier New" pitchFamily="34" charset="0"/>
+                <a:ea typeface="Courier New" pitchFamily="34" charset="-122"/>
+                <a:cs typeface="Courier New" pitchFamily="34" charset="-120"/>
+              </a:rPr>
+              <a:t>01</a:t>
+            </a:r>
+            <a:endParaRPr lang="en-US" sz="1500" dirty="0"/>
+          </a:p>
+        </p:txBody>
+      </p:sp>
+      <p:sp>
+        <p:nvSpPr>
+          <p:cNvPr id="10" name="Text 8"/>
+          <p:cNvSpPr txBox="1"/>
+          <p:nvPr/>
+        </p:nvSpPr>
+        <p:spPr>
+          <a:xfrm>
+            <a:off x="7086600" y="2423160"/>
+            <a:ext cx="4297680" cy="347472"/>
+          </a:xfrm>
+          <a:prstGeom prst="rect">
+            <a:avLst/>
+          </a:prstGeom>
+          <a:noFill/>
+          <a:ln/>
+        </p:spPr>
+        <p:txBody>
+          <a:bodyPr wrap="square" lIns="0" tIns="0" rIns="0" bIns="0" rtlCol="0" anchor="t"/>
+          <a:lstStyle/>
+          <a:p>
+            <a:pPr indent="0" marL="0">
+              <a:buNone/>
+            </a:pPr>
+            <a:r>
+              <a:rPr lang="en-US" sz="1500" b="1" dirty="0">
+                <a:solidFill>
+                  <a:schemeClr val="tx1"/>
+                </a:solidFill>
+              </a:rPr>
+              <a:t>Memory</a:t>
+            </a:r>
+            <a:endParaRPr lang="en-US" sz="1500" dirty="0"/>
+          </a:p>
+        </p:txBody>
+      </p:sp>
+      <p:sp>
+        <p:nvSpPr>
+          <p:cNvPr id="11" name="Text 9"/>
+          <p:cNvSpPr txBox="1"/>
+          <p:nvPr/>
+        </p:nvSpPr>
+        <p:spPr>
+          <a:xfrm>
+            <a:off x="7086600" y="2770632"/>
+            <a:ext cx="4297680" cy="365760"/>
+          </a:xfrm>
+          <a:prstGeom prst="rect">
+            <a:avLst/>
+          </a:prstGeom>
+          <a:noFill/>
+          <a:ln/>
+        </p:spPr>
+        <p:txBody>
+          <a:bodyPr wrap="square" lIns="0" tIns="0" rIns="0" bIns="0" rtlCol="0" anchor="t"/>
+          <a:lstStyle/>
+          <a:p>
+            <a:pPr indent="0" marL="0">
+              <a:buNone/>
+            </a:pPr>
+            <a:r>
+              <a:rPr lang="en-US" sz="1300" dirty="0">
+                <a:solidFill>
+                  <a:schemeClr val="tx2"/>
+                </a:solidFill>
+              </a:rPr>
+              <a:t>LSTM or a belief table of the opponent's cards</a:t>
+            </a:r>
+            <a:endParaRPr lang="en-US" sz="1300" dirty="0"/>
+          </a:p>
+        </p:txBody>
+      </p:sp>
+      <p:sp>
+        <p:nvSpPr>
+          <p:cNvPr id="12" name="Text 10"/>
+          <p:cNvSpPr txBox="1"/>
+          <p:nvPr/>
+        </p:nvSpPr>
+        <p:spPr>
+          <a:xfrm>
+            <a:off x="6492240" y="3291840"/>
+            <a:ext cx="548640" cy="365760"/>
+          </a:xfrm>
+          <a:prstGeom prst="rect">
+            <a:avLst/>
+          </a:prstGeom>
+          <a:noFill/>
+          <a:ln/>
+        </p:spPr>
+        <p:txBody>
+          <a:bodyPr wrap="square" lIns="0" tIns="0" rIns="0" bIns="0" rtlCol="0" anchor="ctr"/>
+          <a:lstStyle/>
+          <a:p>
+            <a:pPr indent="0" marL="0">
+              <a:buNone/>
+            </a:pPr>
+            <a:r>
+              <a:rPr lang="en-US" sz="1500" b="1" dirty="0">
+                <a:solidFill>
+                  <a:schemeClr val="accent1"/>
+                </a:solidFill>
+                <a:latin typeface="Courier New" pitchFamily="34" charset="0"/>
+                <a:ea typeface="Courier New" pitchFamily="34" charset="-122"/>
+                <a:cs typeface="Courier New" pitchFamily="34" charset="-120"/>
+              </a:rPr>
+              <a:t>02</a:t>
+            </a:r>
+            <a:endParaRPr lang="en-US" sz="1500" dirty="0"/>
+          </a:p>
+        </p:txBody>
+      </p:sp>
+      <p:sp>
+        <p:nvSpPr>
+          <p:cNvPr id="13" name="Text 11"/>
+          <p:cNvSpPr txBox="1"/>
+          <p:nvPr/>
+        </p:nvSpPr>
+        <p:spPr>
+          <a:xfrm>
+            <a:off x="7086600" y="3291840"/>
+            <a:ext cx="4297680" cy="347472"/>
+          </a:xfrm>
+          <a:prstGeom prst="rect">
+            <a:avLst/>
+          </a:prstGeom>
+          <a:noFill/>
+          <a:ln/>
+        </p:spPr>
+        <p:txBody>
+          <a:bodyPr wrap="square" lIns="0" tIns="0" rIns="0" bIns="0" rtlCol="0" anchor="t"/>
+          <a:lstStyle/>
+          <a:p>
+            <a:pPr indent="0" marL="0">
+              <a:buNone/>
+            </a:pPr>
+            <a:r>
+              <a:rPr lang="en-US" sz="1500" b="1" dirty="0">
+                <a:solidFill>
+                  <a:schemeClr val="tx1"/>
+                </a:solidFill>
+              </a:rPr>
+              <a:t>League self-play</a:t>
+            </a:r>
+            <a:endParaRPr lang="en-US" sz="1500" dirty="0"/>
+          </a:p>
+        </p:txBody>
+      </p:sp>
+      <p:sp>
+        <p:nvSpPr>
+          <p:cNvPr id="14" name="Text 12"/>
+          <p:cNvSpPr txBox="1"/>
+          <p:nvPr/>
+        </p:nvSpPr>
+        <p:spPr>
+          <a:xfrm>
+            <a:off x="7086600" y="3639312"/>
+            <a:ext cx="4297680" cy="365760"/>
+          </a:xfrm>
+          <a:prstGeom prst="rect">
+            <a:avLst/>
+          </a:prstGeom>
+          <a:noFill/>
+          <a:ln/>
+        </p:spPr>
+        <p:txBody>
+          <a:bodyPr wrap="square" lIns="0" tIns="0" rIns="0" bIns="0" rtlCol="0" anchor="t"/>
+          <a:lstStyle/>
+          <a:p>
+            <a:pPr indent="0" marL="0">
+              <a:buNone/>
+            </a:pPr>
+            <a:r>
+              <a:rPr lang="en-US" sz="1300" dirty="0">
+                <a:solidFill>
+                  <a:schemeClr val="tx2"/>
+                </a:solidFill>
+              </a:rPr>
+              <a:t>Train against a pool of past versions</a:t>
+            </a:r>
+            <a:endParaRPr lang="en-US" sz="1300" dirty="0"/>
+          </a:p>
+        </p:txBody>
+      </p:sp>
+      <p:sp>
+        <p:nvSpPr>
+          <p:cNvPr id="15" name="Text 13"/>
+          <p:cNvSpPr txBox="1"/>
+          <p:nvPr/>
+        </p:nvSpPr>
+        <p:spPr>
+          <a:xfrm>
+            <a:off x="6492240" y="4160520"/>
+            <a:ext cx="548640" cy="365760"/>
+          </a:xfrm>
+          <a:prstGeom prst="rect">
+            <a:avLst/>
+          </a:prstGeom>
+          <a:noFill/>
+          <a:ln/>
+        </p:spPr>
+        <p:txBody>
+          <a:bodyPr wrap="square" lIns="0" tIns="0" rIns="0" bIns="0" rtlCol="0" anchor="ctr"/>
+          <a:lstStyle/>
+          <a:p>
+            <a:pPr indent="0" marL="0">
+              <a:buNone/>
+            </a:pPr>
+            <a:r>
+              <a:rPr lang="en-US" sz="1500" b="1" dirty="0">
+                <a:solidFill>
+                  <a:schemeClr val="accent1"/>
+                </a:solidFill>
+                <a:latin typeface="Courier New" pitchFamily="34" charset="0"/>
+                <a:ea typeface="Courier New" pitchFamily="34" charset="-122"/>
+                <a:cs typeface="Courier New" pitchFamily="34" charset="-120"/>
+              </a:rPr>
+              <a:t>03</a:t>
+            </a:r>
+            <a:endParaRPr lang="en-US" sz="1500" dirty="0"/>
+          </a:p>
+        </p:txBody>
+      </p:sp>
+      <p:sp>
+        <p:nvSpPr>
+          <p:cNvPr id="16" name="Text 14"/>
+          <p:cNvSpPr txBox="1"/>
+          <p:nvPr/>
+        </p:nvSpPr>
+        <p:spPr>
+          <a:xfrm>
+            <a:off x="7086600" y="4160520"/>
+            <a:ext cx="4297680" cy="347472"/>
+          </a:xfrm>
+          <a:prstGeom prst="rect">
+            <a:avLst/>
+          </a:prstGeom>
+          <a:noFill/>
+          <a:ln/>
+        </p:spPr>
+        <p:txBody>
+          <a:bodyPr wrap="square" lIns="0" tIns="0" rIns="0" bIns="0" rtlCol="0" anchor="t"/>
+          <a:lstStyle/>
+          <a:p>
+            <a:pPr indent="0" marL="0">
+              <a:buNone/>
+            </a:pPr>
+            <a:r>
+              <a:rPr lang="en-US" sz="1500" b="1" dirty="0">
+                <a:solidFill>
+                  <a:schemeClr val="tx1"/>
+                </a:solidFill>
+              </a:rPr>
+              <a:t>Trump choice</a:t>
+            </a:r>
+            <a:endParaRPr lang="en-US" sz="1500" dirty="0"/>
+          </a:p>
+        </p:txBody>
+      </p:sp>
+      <p:sp>
+        <p:nvSpPr>
+          <p:cNvPr id="17" name="Text 15"/>
+          <p:cNvSpPr txBox="1"/>
+          <p:nvPr/>
+        </p:nvSpPr>
+        <p:spPr>
+          <a:xfrm>
+            <a:off x="7086600" y="4507992"/>
+            <a:ext cx="4297680" cy="365760"/>
+          </a:xfrm>
+          <a:prstGeom prst="rect">
+            <a:avLst/>
+          </a:prstGeom>
+          <a:noFill/>
+          <a:ln/>
+        </p:spPr>
+        <p:txBody>
+          <a:bodyPr wrap="square" lIns="0" tIns="0" rIns="0" bIns="0" rtlCol="0" anchor="t"/>
+          <a:lstStyle/>
+          <a:p>
+            <a:pPr indent="0" marL="0">
+              <a:buNone/>
+            </a:pPr>
+            <a:r>
+              <a:rPr lang="en-US" sz="1300" dirty="0">
+                <a:solidFill>
+                  <a:schemeClr val="tx2"/>
+                </a:solidFill>
+              </a:rPr>
+              <a:t>Let the agent bid the trump suit (Phase 4)</a:t>
+            </a:r>
+            <a:endParaRPr lang="en-US" sz="1300" dirty="0"/>
+          </a:p>
+        </p:txBody>
+      </p:sp>
+      <p:sp>
+        <p:nvSpPr>
+          <p:cNvPr id="18" name="Text 16"/>
+          <p:cNvSpPr txBox="1"/>
+          <p:nvPr/>
+        </p:nvSpPr>
+        <p:spPr>
+          <a:xfrm>
+            <a:off x="6492240" y="5029200"/>
+            <a:ext cx="548640" cy="365760"/>
+          </a:xfrm>
+          <a:prstGeom prst="rect">
+            <a:avLst/>
+          </a:prstGeom>
+          <a:noFill/>
+          <a:ln/>
+        </p:spPr>
+        <p:txBody>
+          <a:bodyPr wrap="square" lIns="0" tIns="0" rIns="0" bIns="0" rtlCol="0" anchor="ctr"/>
+          <a:lstStyle/>
+          <a:p>
+            <a:pPr indent="0" marL="0">
+              <a:buNone/>
+            </a:pPr>
+            <a:r>
+              <a:rPr lang="en-US" sz="1500" b="1" dirty="0">
+                <a:solidFill>
+                  <a:schemeClr val="accent1"/>
+                </a:solidFill>
+                <a:latin typeface="Courier New" pitchFamily="34" charset="0"/>
+                <a:ea typeface="Courier New" pitchFamily="34" charset="-122"/>
+                <a:cs typeface="Courier New" pitchFamily="34" charset="-120"/>
+              </a:rPr>
+              <a:t>04</a:t>
+            </a:r>
+            <a:endParaRPr lang="en-US" sz="1500" dirty="0"/>
+          </a:p>
+        </p:txBody>
+      </p:sp>
+      <p:sp>
+        <p:nvSpPr>
+          <p:cNvPr id="19" name="Text 17"/>
+          <p:cNvSpPr txBox="1"/>
+          <p:nvPr/>
+        </p:nvSpPr>
+        <p:spPr>
+          <a:xfrm>
+            <a:off x="7086600" y="5029200"/>
+            <a:ext cx="4297680" cy="347472"/>
+          </a:xfrm>
+          <a:prstGeom prst="rect">
+            <a:avLst/>
+          </a:prstGeom>
+          <a:noFill/>
+          <a:ln/>
+        </p:spPr>
+        <p:txBody>
+          <a:bodyPr wrap="square" lIns="0" tIns="0" rIns="0" bIns="0" rtlCol="0" anchor="t"/>
+          <a:lstStyle/>
+          <a:p>
+            <a:pPr indent="0" marL="0">
+              <a:buNone/>
+            </a:pPr>
+            <a:r>
+              <a:rPr lang="en-US" sz="1500" b="1" dirty="0">
+                <a:solidFill>
+                  <a:schemeClr val="tx1"/>
+                </a:solidFill>
+              </a:rPr>
+              <a:t>Human vs agent</a:t>
+            </a:r>
+            <a:endParaRPr lang="en-US" sz="1500" dirty="0"/>
+          </a:p>
+        </p:txBody>
+      </p:sp>
+      <p:sp>
+        <p:nvSpPr>
+          <p:cNvPr id="20" name="Text 18"/>
+          <p:cNvSpPr txBox="1"/>
+          <p:nvPr/>
+        </p:nvSpPr>
+        <p:spPr>
+          <a:xfrm>
+            <a:off x="7086600" y="5376672"/>
+            <a:ext cx="4297680" cy="365760"/>
+          </a:xfrm>
+          <a:prstGeom prst="rect">
+            <a:avLst/>
+          </a:prstGeom>
+          <a:noFill/>
+          <a:ln/>
+        </p:spPr>
+        <p:txBody>
+          <a:bodyPr wrap="square" lIns="0" tIns="0" rIns="0" bIns="0" rtlCol="0" anchor="t"/>
+          <a:lstStyle/>
+          <a:p>
+            <a:pPr indent="0" marL="0">
+              <a:buNone/>
+            </a:pPr>
+            <a:r>
+              <a:rPr lang="en-US" sz="1300" dirty="0">
+                <a:solidFill>
+                  <a:schemeClr val="tx2"/>
+                </a:solidFill>
+              </a:rPr>
+              <a:t>Plug the trained agent into the playable CLI</a:t>
+            </a:r>
+            <a:endParaRPr lang="en-US" sz="1300" dirty="0"/>
+          </a:p>
+        </p:txBody>
+      </p:sp>
+      <p:sp>
+        <p:nvSpPr>
+          <p:cNvPr id="25" name="Slide Number Placeholder 0"/>
+          <p:cNvSpPr>
+            <a:spLocks noGrp="1"/>
+          </p:cNvSpPr>
+          <p:nvPr>
+            <p:ph type="sldNum" sz="quarter" idx="4294967295"/>
+          </p:nvPr>
+        </p:nvSpPr>
+        <p:spPr>
+          <a:xfrm>
+            <a:off x="11109960" y="6382512"/>
+            <a:ext cx="548640" cy="274320"/>
+          </a:xfrm>
+          <a:prstGeom prst="rect">
+            <a:avLst/>
+          </a:prstGeom>
+          <a:extLst>
+            <a:ext uri="{C572A759-6A51-4108-AA02-DFA0A04FC94B}">
+              <ma14:wrappingTextBoxFlag xmlns:ma14="http://schemas.microsoft.com/office/mac/drawingml/2011/main" val="0"/>
+            </a:ext>
+          </a:extLst>
+        </p:spPr>
+        <p:txBody>
+          <a:bodyPr/>
+          <a:lstStyle>
+            <a:lvl1pPr>
+              <a:defRPr sz="900">
+                <a:solidFill>
+                  <a:schemeClr val="tx2"/>
+                </a:solidFill>
+                <a:latin typeface="Courier New"/>
+                <a:ea typeface="Courier New"/>
+                <a:cs typeface="Courier New"/>
+              </a:defRPr>
+            </a:lvl1pPr>
+          </a:lstStyle>
+          <a:p>
+            <a:pPr algn="r"/>
+            <a:fld id="{F7021451-1387-4CA6-816F-3879F97B5CBC}" type="slidenum">
+              <a:rPr b="0" lang="en-US"/>
+              <a:t>17</a:t>
+            </a:fld>
+            <a:endParaRPr lang="en-US"/>
+          </a:p>
+        </p:txBody>
+      </p:sp>
+    </p:spTree>
+  </p:cSld>
+  <p:clrMapOvr>
+    <a:masterClrMapping/>
+  </p:clrMapOvr>
+</p:sld>
+</file>
+
+<file path=ppt/slides/slide18.xml><?xml version="1.0" encoding="utf-8"?>
+<p:sld xmlns:a="http://schemas.openxmlformats.org/drawingml/2006/main" xmlns:r="http://schemas.openxmlformats.org/officeDocument/2006/relationships" xmlns:p="http://schemas.openxmlformats.org/presentationml/2006/main">
+  <p:cSld name="Slide 18">
     <p:spTree>
       <p:nvGrpSpPr>
         <p:cNvPr id="1" name=""/>

</xml_diff>

<commit_message>
présentation : le 10 entamé est un pari, next steps à jour
- Slide 16 : le cadre « STILL WRONG — weak memory » était tiré d'une seule
  donne. Mesuré sur 3 000 manches : l'agent entame un 10 avec l'As non vu
  dans 6,6 % de ses entames, et l'adversaire n'a l'As que dans 15 % de ces
  cas (16 cartes jamais distribuées). Remplacé par « A CALCULATED RISK ».
- Slide 17 : le tableau des cartes possibles (testé, sans gain mesurable)
  et la démo humain contre agent (faite) sortent de « Next » ; ajout de la
  démo dans « Done », du réseau plus gros et du rapport final dans « Next ».

Co-Authored-By: Claude Opus 5.5 <noreply@anthropic.com>
</commit_message>
<xml_diff>
--- a/presentation/belote_midterm_v3.pptx
+++ b/presentation/belote_midterm_v3.pptx
@@ -124,7 +124,7 @@
   <p:extLst>
     <p:ext uri="{521415D9-36F7-43E2-AB2F-B90AF26B5E84}">
       <p14:sectionLst xmlns:p14="http://schemas.microsoft.com/office/powerpoint/2010/main">
-        <p14:section name="Introduction" id="{fc6d4f49-ee7f-ded1-8d09-eccfae58461c}">
+        <p14:section name="Introduction" id="{2e722f80-95ee-ad41-5cdb-e27568dd0281}">
           <p14:sldIdLst>
             <p14:sldId id="256"/>
             <p14:sldId id="257"/>
@@ -132,7 +132,7 @@
             <p14:sldId id="259"/>
           </p14:sldIdLst>
         </p14:section>
-        <p14:section name="Method" id="{656c7ef6-cda5-453d-d750-21605f5fc3bb}">
+        <p14:section name="Method" id="{d7f804af-9cee-4f13-8918-b7c2b27097ba}">
           <p14:sldIdLst>
             <p14:sldId id="260"/>
             <p14:sldId id="261"/>
@@ -140,7 +140,7 @@
             <p14:sldId id="263"/>
           </p14:sldIdLst>
         </p14:section>
-        <p14:section name="Results" id="{00cd0240-745e-488d-1a88-4ac07974b726}">
+        <p14:section name="Results" id="{c26619ab-2900-235c-0a91-90eef21fdd04}">
           <p14:sldIdLst>
             <p14:sldId id="264"/>
             <p14:sldId id="265"/>
@@ -152,7 +152,7 @@
             <p14:sldId id="271"/>
           </p14:sldIdLst>
         </p14:section>
-        <p14:section name="Conclusion" id="{6e7c90c9-9d2a-a930-9f2d-9df343ffaec1}">
+        <p14:section name="Conclusion" id="{0ba3f1e6-4adb-f3be-6145-486c2f0522b4}">
           <p14:sldIdLst>
             <p14:sldId id="272"/>
             <p14:sldId id="273"/>
@@ -2040,7 +2040,7 @@
           <a:p>
             <a:r>
               <a:rPr lang="en-US" dirty="0"/>
-              <a:t/>
+              <a:t>Measured over 3 000 rounds vs TrumpCount: 743 such Ten leads out of 11 246 leads; the opponent actually held the Ace in 114 of them (15%). The deal we lost 21 points on was one of the unlucky 15%, not a memory error. Adding an explicit table of the opponent's possible cards did not change this behaviour or the results.</a:t>
             </a:r>
             <a:endParaRPr lang="en-US" dirty="0"/>
           </a:p>
@@ -11329,7 +11329,7 @@
       </p:sp>
       <p:sp>
         <p:nvSpPr>
-          <p:cNvPr id="34" name="mistake card"/>
+          <p:cNvPr id="34" name="calculated risk card"/>
           <p:cNvSpPr/>
           <p:nvPr/>
         </p:nvSpPr>
@@ -11381,13 +11381,13 @@
             <a:r>
               <a:rPr lang="en-US" sz="1100" b="1" dirty="0">
                 <a:solidFill>
-                  <a:schemeClr val="accent2"/>
+                  <a:schemeClr val="accent1"/>
                 </a:solidFill>
                 <a:latin typeface="Courier New" pitchFamily="34" charset="0"/>
                 <a:ea typeface="Courier New" pitchFamily="34" charset="-122"/>
                 <a:cs typeface="Courier New" pitchFamily="34" charset="-120"/>
               </a:rPr>
-              <a:t>STILL WRONG</a:t>
+              <a:t>A CALCULATED RISK</a:t>
             </a:r>
             <a:endParaRPr lang="en-US" sz="1100" dirty="0"/>
           </a:p>
@@ -11423,7 +11423,7 @@
                   <a:schemeClr val="tx1"/>
                 </a:solidFill>
               </a:rPr>
-              <a:t>Leads a Ten while the Ace is still out (−21 pts), with 100% confidence.</a:t>
+              <a:t>Leads a Ten with the Ace unseen in 6.6% of its leads.</a:t>
             </a:r>
             <a:endParaRPr lang="en-US" sz="1300" dirty="0"/>
           </a:p>
@@ -11437,7 +11437,7 @@
                   <a:schemeClr val="accent1"/>
                 </a:solidFill>
               </a:rPr>
-              <a:t>→ weak memory of which high cards remain.</a:t>
+              <a:t>16 cards are never dealt: the opponent holds that Ace only 15% of the time.</a:t>
             </a:r>
             <a:endParaRPr lang="en-US" sz="1300" dirty="0"/>
           </a:p>
@@ -11771,6 +11771,24 @@
             </a:r>
             <a:endParaRPr lang="en-US" sz="1500" dirty="0"/>
           </a:p>
+          <a:p>
+            <a:pPr marL="203200" indent="-203200">
+              <a:spcAft>
+                <a:spcPts val="800"/>
+              </a:spcAft>
+              <a:buSzPct val="100000"/>
+              <a:buChar char="•"/>
+            </a:pPr>
+            <a:r>
+              <a:rPr lang="en-US" sz="1400" dirty="0">
+                <a:solidFill>
+                  <a:schemeClr val="tx1"/>
+                </a:solidFill>
+              </a:rPr>
+              <a:t>Playable web demo: humans vs the trained agent</a:t>
+            </a:r>
+            <a:endParaRPr lang="en-US" sz="1500" dirty="0"/>
+          </a:p>
         </p:txBody>
       </p:sp>
       <p:sp>
@@ -11908,7 +11926,7 @@
                   <a:schemeClr val="tx1"/>
                 </a:solidFill>
               </a:rPr>
-              <a:t>Memory</a:t>
+              <a:t>League self-play</a:t>
             </a:r>
             <a:endParaRPr lang="en-US" sz="1500" dirty="0"/>
           </a:p>
@@ -11944,7 +11962,7 @@
                   <a:schemeClr val="tx2"/>
                 </a:solidFill>
               </a:rPr>
-              <a:t>LSTM or a belief table of the opponent's cards</a:t>
+              <a:t>Train against a pool of past versions to pass the plateau</a:t>
             </a:r>
             <a:endParaRPr lang="en-US" sz="1300" dirty="0"/>
           </a:p>
@@ -12019,7 +12037,7 @@
                   <a:schemeClr val="tx1"/>
                 </a:solidFill>
               </a:rPr>
-              <a:t>League self-play</a:t>
+              <a:t>Bigger network</a:t>
             </a:r>
             <a:endParaRPr lang="en-US" sz="1500" dirty="0"/>
           </a:p>
@@ -12055,7 +12073,7 @@
                   <a:schemeClr val="tx2"/>
                 </a:solidFill>
               </a:rPr>
-              <a:t>Train against a pool of past versions</a:t>
+              <a:t>More capacity than 2 × 128 units</a:t>
             </a:r>
             <a:endParaRPr lang="en-US" sz="1300" dirty="0"/>
           </a:p>
@@ -12241,7 +12259,7 @@
                   <a:schemeClr val="tx1"/>
                 </a:solidFill>
               </a:rPr>
-              <a:t>Human vs agent</a:t>
+              <a:t>Final report</a:t>
             </a:r>
             <a:endParaRPr lang="en-US" sz="1500" dirty="0"/>
           </a:p>
@@ -12277,7 +12295,7 @@
                   <a:schemeClr val="tx2"/>
                 </a:solidFill>
               </a:rPr>
-              <a:t>Plug the trained agent into the playable CLI</a:t>
+              <a:t>Ablations, behaviour statistics, write-up</a:t>
             </a:r>
             <a:endParaRPr lang="en-US" sz="1300" dirty="0"/>
           </a:p>

</xml_diff>